<commit_message>
Árboles de problemas: color institucional azul ANIN
Cambia el verde (#1B4D2E) por el azul institucional ANIN (#1B4F72) en
la página HTML, las láminas PowerPoint y el diagrama draw.io: banda de
encabezado, problema central, causas, pestañas y tablas. La página HTML
del repositorio pasa a ser un documento completo que se abre tal cual.

Co-Authored-By: Claude Opus 5.5 <noreply@anthropic.com>
Claude-Session: https://claude.ai/code/session_011TLfW4bPfHxnSbkwk5UFi8
</commit_message>
<xml_diff>
--- a/arboles_problemas/Arboles_Problemas_IN_Piura.pptx
+++ b/arboles_problemas/Arboles_Problemas_IN_Piura.pptx
@@ -3740,7 +3740,7 @@
           </a:prstGeom>
           <a:ln w="15875">
             <a:solidFill>
-              <a:srgbClr val="4A5A50"/>
+              <a:srgbClr val="4A5867"/>
             </a:solidFill>
             <a:headEnd type="triangle" w="med" len="med"/>
           </a:ln>
@@ -3779,7 +3779,7 @@
           </a:prstGeom>
           <a:ln w="15875">
             <a:solidFill>
-              <a:srgbClr val="4A5A50"/>
+              <a:srgbClr val="4A5867"/>
             </a:solidFill>
             <a:headEnd type="triangle" w="med" len="med"/>
           </a:ln>
@@ -3818,7 +3818,7 @@
           </a:prstGeom>
           <a:ln w="15875">
             <a:solidFill>
-              <a:srgbClr val="4A5A50"/>
+              <a:srgbClr val="4A5867"/>
             </a:solidFill>
             <a:headEnd type="triangle" w="med" len="med"/>
           </a:ln>
@@ -3857,7 +3857,7 @@
           </a:prstGeom>
           <a:ln w="15875">
             <a:solidFill>
-              <a:srgbClr val="4A5A50"/>
+              <a:srgbClr val="4A5867"/>
             </a:solidFill>
             <a:headEnd type="triangle" w="med" len="med"/>
           </a:ln>
@@ -3896,7 +3896,7 @@
           </a:prstGeom>
           <a:ln w="15875">
             <a:solidFill>
-              <a:srgbClr val="4A5A50"/>
+              <a:srgbClr val="4A5867"/>
             </a:solidFill>
             <a:headEnd type="triangle" w="med" len="med"/>
           </a:ln>
@@ -3935,7 +3935,7 @@
           </a:prstGeom>
           <a:ln w="15875">
             <a:solidFill>
-              <a:srgbClr val="4A5A50"/>
+              <a:srgbClr val="4A5867"/>
             </a:solidFill>
             <a:headEnd type="triangle" w="med" len="med"/>
           </a:ln>
@@ -3974,7 +3974,7 @@
           </a:prstGeom>
           <a:ln w="15875">
             <a:solidFill>
-              <a:srgbClr val="4A5A50"/>
+              <a:srgbClr val="4A5867"/>
             </a:solidFill>
             <a:headEnd type="triangle" w="med" len="med"/>
           </a:ln>
@@ -4013,7 +4013,7 @@
           </a:prstGeom>
           <a:ln w="15875">
             <a:solidFill>
-              <a:srgbClr val="4A5A50"/>
+              <a:srgbClr val="4A5867"/>
             </a:solidFill>
             <a:headEnd type="triangle" w="med" len="med"/>
           </a:ln>
@@ -4052,7 +4052,7 @@
           </a:prstGeom>
           <a:ln w="15875">
             <a:solidFill>
-              <a:srgbClr val="4A5A50"/>
+              <a:srgbClr val="4A5867"/>
             </a:solidFill>
             <a:headEnd type="triangle" w="med" len="med"/>
           </a:ln>
@@ -4091,7 +4091,7 @@
           </a:prstGeom>
           <a:ln w="15875">
             <a:solidFill>
-              <a:srgbClr val="4A5A50"/>
+              <a:srgbClr val="4A5867"/>
             </a:solidFill>
             <a:headEnd type="triangle" w="med" len="med"/>
           </a:ln>
@@ -4130,7 +4130,7 @@
           </a:prstGeom>
           <a:ln w="15875">
             <a:solidFill>
-              <a:srgbClr val="4A5A50"/>
+              <a:srgbClr val="4A5867"/>
             </a:solidFill>
             <a:headEnd type="triangle" w="med" len="med"/>
           </a:ln>
@@ -4169,7 +4169,7 @@
           </a:prstGeom>
           <a:ln w="15875">
             <a:solidFill>
-              <a:srgbClr val="4A5A50"/>
+              <a:srgbClr val="4A5867"/>
             </a:solidFill>
             <a:headEnd type="triangle" w="med" len="med"/>
           </a:ln>
@@ -4208,7 +4208,7 @@
           </a:prstGeom>
           <a:ln w="15875">
             <a:solidFill>
-              <a:srgbClr val="4A5A50"/>
+              <a:srgbClr val="4A5867"/>
             </a:solidFill>
             <a:headEnd type="triangle" w="med" len="med"/>
           </a:ln>
@@ -4247,7 +4247,7 @@
           </a:prstGeom>
           <a:ln w="15875">
             <a:solidFill>
-              <a:srgbClr val="4A5A50"/>
+              <a:srgbClr val="4A5867"/>
             </a:solidFill>
             <a:headEnd type="triangle" w="med" len="med"/>
           </a:ln>
@@ -4286,7 +4286,7 @@
           </a:prstGeom>
           <a:ln w="15875">
             <a:solidFill>
-              <a:srgbClr val="4A5A50"/>
+              <a:srgbClr val="4A5867"/>
             </a:solidFill>
             <a:headEnd type="triangle" w="med" len="med"/>
           </a:ln>
@@ -4325,7 +4325,7 @@
           </a:prstGeom>
           <a:ln w="15875">
             <a:solidFill>
-              <a:srgbClr val="4A5A50"/>
+              <a:srgbClr val="4A5867"/>
             </a:solidFill>
           </a:ln>
         </p:spPr>
@@ -4363,7 +4363,7 @@
           </a:prstGeom>
           <a:ln w="15875">
             <a:solidFill>
-              <a:srgbClr val="4A5A50"/>
+              <a:srgbClr val="4A5867"/>
             </a:solidFill>
           </a:ln>
         </p:spPr>
@@ -4401,7 +4401,7 @@
           </a:prstGeom>
           <a:ln w="15875">
             <a:solidFill>
-              <a:srgbClr val="4A5A50"/>
+              <a:srgbClr val="4A5867"/>
             </a:solidFill>
           </a:ln>
         </p:spPr>
@@ -4439,7 +4439,7 @@
           </a:prstGeom>
           <a:ln w="15875">
             <a:solidFill>
-              <a:srgbClr val="4A5A50"/>
+              <a:srgbClr val="4A5867"/>
             </a:solidFill>
           </a:ln>
         </p:spPr>
@@ -4477,7 +4477,7 @@
           </a:prstGeom>
           <a:ln w="15875">
             <a:solidFill>
-              <a:srgbClr val="4A5A50"/>
+              <a:srgbClr val="4A5867"/>
             </a:solidFill>
           </a:ln>
         </p:spPr>
@@ -4515,7 +4515,7 @@
           </a:prstGeom>
           <a:ln w="15875">
             <a:solidFill>
-              <a:srgbClr val="4A5A50"/>
+              <a:srgbClr val="4A5867"/>
             </a:solidFill>
           </a:ln>
         </p:spPr>
@@ -4553,7 +4553,7 @@
           </a:prstGeom>
           <a:ln w="15875">
             <a:solidFill>
-              <a:srgbClr val="4A5A50"/>
+              <a:srgbClr val="4A5867"/>
             </a:solidFill>
           </a:ln>
         </p:spPr>
@@ -4591,7 +4591,7 @@
           </a:prstGeom>
           <a:ln w="15875">
             <a:solidFill>
-              <a:srgbClr val="4A5A50"/>
+              <a:srgbClr val="4A5867"/>
             </a:solidFill>
           </a:ln>
         </p:spPr>
@@ -4629,7 +4629,7 @@
           </a:prstGeom>
           <a:ln w="15875">
             <a:solidFill>
-              <a:srgbClr val="4A5A50"/>
+              <a:srgbClr val="4A5867"/>
             </a:solidFill>
           </a:ln>
         </p:spPr>
@@ -4667,7 +4667,7 @@
           </a:prstGeom>
           <a:ln w="15875">
             <a:solidFill>
-              <a:srgbClr val="4A5A50"/>
+              <a:srgbClr val="4A5867"/>
             </a:solidFill>
           </a:ln>
         </p:spPr>
@@ -4705,7 +4705,7 @@
           </a:prstGeom>
           <a:ln w="15875">
             <a:solidFill>
-              <a:srgbClr val="4A5A50"/>
+              <a:srgbClr val="4A5867"/>
             </a:solidFill>
             <a:headEnd type="triangle" w="med" len="med"/>
           </a:ln>
@@ -4744,7 +4744,7 @@
           </a:prstGeom>
           <a:ln w="15875">
             <a:solidFill>
-              <a:srgbClr val="4A5A50"/>
+              <a:srgbClr val="4A5867"/>
             </a:solidFill>
             <a:headEnd type="triangle" w="med" len="med"/>
           </a:ln>
@@ -4783,7 +4783,7 @@
           </a:prstGeom>
           <a:ln w="15875">
             <a:solidFill>
-              <a:srgbClr val="4A5A50"/>
+              <a:srgbClr val="4A5867"/>
             </a:solidFill>
             <a:headEnd type="triangle" w="med" len="med"/>
           </a:ln>
@@ -4822,7 +4822,7 @@
           </a:prstGeom>
           <a:ln w="15875">
             <a:solidFill>
-              <a:srgbClr val="6B7A70"/>
+              <a:srgbClr val="6B7A89"/>
             </a:solidFill>
             <a:prstDash val="dash"/>
             <a:tailEnd type="triangle"/>
@@ -4862,7 +4862,7 @@
           </a:prstGeom>
           <a:ln w="15875">
             <a:solidFill>
-              <a:srgbClr val="6B7A70"/>
+              <a:srgbClr val="6B7A89"/>
             </a:solidFill>
             <a:prstDash val="dash"/>
             <a:tailEnd type="triangle"/>
@@ -4898,7 +4898,7 @@
             <a:avLst/>
           </a:prstGeom>
           <a:solidFill>
-            <a:srgbClr val="1B4D2E"/>
+            <a:srgbClr val="1B4F72"/>
           </a:solidFill>
           <a:ln>
             <a:noFill/>
@@ -4986,7 +4986,7 @@
             <a:r>
               <a:rPr sz="750" b="0" i="0">
                 <a:solidFill>
-                  <a:srgbClr val="5B6B61"/>
+                  <a:srgbClr val="55677A"/>
                 </a:solidFill>
                 <a:latin typeface="Arial"/>
               </a:rPr>
@@ -5098,7 +5098,7 @@
             <a:r>
               <a:rPr sz="955" b="1" i="0">
                 <a:solidFill>
-                  <a:srgbClr val="1E2A22"/>
+                  <a:srgbClr val="1B2733"/>
                 </a:solidFill>
                 <a:latin typeface="Arial"/>
               </a:rPr>
@@ -5107,7 +5107,7 @@
             <a:r>
               <a:rPr sz="1225" b="0" i="0">
                 <a:solidFill>
-                  <a:srgbClr val="1E2A22"/>
+                  <a:srgbClr val="1B2733"/>
                 </a:solidFill>
                 <a:latin typeface="Arial"/>
               </a:rPr>
@@ -5162,7 +5162,7 @@
             <a:r>
               <a:rPr sz="955" b="1" i="0">
                 <a:solidFill>
-                  <a:srgbClr val="1E2A22"/>
+                  <a:srgbClr val="1B2733"/>
                 </a:solidFill>
                 <a:latin typeface="Arial"/>
               </a:rPr>
@@ -5171,7 +5171,7 @@
             <a:r>
               <a:rPr sz="1225" b="0" i="0">
                 <a:solidFill>
-                  <a:srgbClr val="1E2A22"/>
+                  <a:srgbClr val="1B2733"/>
                 </a:solidFill>
                 <a:latin typeface="Arial"/>
               </a:rPr>
@@ -5226,7 +5226,7 @@
             <a:r>
               <a:rPr sz="955" b="1" i="0">
                 <a:solidFill>
-                  <a:srgbClr val="1E2A22"/>
+                  <a:srgbClr val="1B2733"/>
                 </a:solidFill>
                 <a:latin typeface="Arial"/>
               </a:rPr>
@@ -5235,7 +5235,7 @@
             <a:r>
               <a:rPr sz="1225" b="0" i="0">
                 <a:solidFill>
-                  <a:srgbClr val="1E2A22"/>
+                  <a:srgbClr val="1B2733"/>
                 </a:solidFill>
                 <a:latin typeface="Arial"/>
               </a:rPr>
@@ -5290,7 +5290,7 @@
             <a:r>
               <a:rPr sz="955" b="1" i="0">
                 <a:solidFill>
-                  <a:srgbClr val="1E2A22"/>
+                  <a:srgbClr val="1B2733"/>
                 </a:solidFill>
                 <a:latin typeface="Arial"/>
               </a:rPr>
@@ -5299,7 +5299,7 @@
             <a:r>
               <a:rPr sz="1225" b="0" i="0">
                 <a:solidFill>
-                  <a:srgbClr val="1E2A22"/>
+                  <a:srgbClr val="1B2733"/>
                 </a:solidFill>
                 <a:latin typeface="Arial"/>
               </a:rPr>
@@ -5354,7 +5354,7 @@
             <a:r>
               <a:rPr sz="955" b="1" i="0">
                 <a:solidFill>
-                  <a:srgbClr val="1E2A22"/>
+                  <a:srgbClr val="1B2733"/>
                 </a:solidFill>
                 <a:latin typeface="Arial"/>
               </a:rPr>
@@ -5363,7 +5363,7 @@
             <a:r>
               <a:rPr sz="1225" b="0" i="0">
                 <a:solidFill>
-                  <a:srgbClr val="1E2A22"/>
+                  <a:srgbClr val="1B2733"/>
                 </a:solidFill>
                 <a:latin typeface="Arial"/>
               </a:rPr>
@@ -5418,7 +5418,7 @@
             <a:r>
               <a:rPr sz="1014" b="1" i="0">
                 <a:solidFill>
-                  <a:srgbClr val="1E2A22"/>
+                  <a:srgbClr val="1B2733"/>
                 </a:solidFill>
                 <a:latin typeface="Arial"/>
               </a:rPr>
@@ -5427,7 +5427,7 @@
             <a:r>
               <a:rPr sz="1300" b="1" i="0">
                 <a:solidFill>
-                  <a:srgbClr val="1E2A22"/>
+                  <a:srgbClr val="1B2733"/>
                 </a:solidFill>
                 <a:latin typeface="Arial"/>
               </a:rPr>
@@ -5482,7 +5482,7 @@
             <a:r>
               <a:rPr sz="1014" b="1" i="0">
                 <a:solidFill>
-                  <a:srgbClr val="1E2A22"/>
+                  <a:srgbClr val="1B2733"/>
                 </a:solidFill>
                 <a:latin typeface="Arial"/>
               </a:rPr>
@@ -5491,7 +5491,7 @@
             <a:r>
               <a:rPr sz="1300" b="1" i="0">
                 <a:solidFill>
-                  <a:srgbClr val="1E2A22"/>
+                  <a:srgbClr val="1B2733"/>
                 </a:solidFill>
                 <a:latin typeface="Arial"/>
               </a:rPr>
@@ -5546,7 +5546,7 @@
             <a:r>
               <a:rPr sz="1014" b="1" i="0">
                 <a:solidFill>
-                  <a:srgbClr val="1E2A22"/>
+                  <a:srgbClr val="1B2733"/>
                 </a:solidFill>
                 <a:latin typeface="Arial"/>
               </a:rPr>
@@ -5555,7 +5555,7 @@
             <a:r>
               <a:rPr sz="1300" b="1" i="0">
                 <a:solidFill>
-                  <a:srgbClr val="1E2A22"/>
+                  <a:srgbClr val="1B2733"/>
                 </a:solidFill>
                 <a:latin typeface="Arial"/>
               </a:rPr>
@@ -5581,11 +5581,11 @@
             </a:avLst>
           </a:prstGeom>
           <a:solidFill>
-            <a:srgbClr val="1B4D2E"/>
+            <a:srgbClr val="1B4F72"/>
           </a:solidFill>
           <a:ln w="12700">
             <a:solidFill>
-              <a:srgbClr val="1B4D2E"/>
+              <a:srgbClr val="1B4F72"/>
             </a:solidFill>
           </a:ln>
           <a:effectLst/>
@@ -5640,7 +5640,7 @@
           </a:solidFill>
           <a:ln w="12700">
             <a:solidFill>
-              <a:srgbClr val="6B7A70"/>
+              <a:srgbClr val="6B7A89"/>
             </a:solidFill>
             <a:prstDash val="dash"/>
           </a:ln>
@@ -5668,7 +5668,7 @@
             <a:r>
               <a:rPr sz="1100" b="1" i="0">
                 <a:solidFill>
-                  <a:srgbClr val="5B6B61"/>
+                  <a:srgbClr val="55677A"/>
                 </a:solidFill>
                 <a:latin typeface="Arial"/>
               </a:rPr>
@@ -5680,7 +5680,7 @@
             <a:r>
               <a:rPr sz="1100" b="0" i="0">
                 <a:solidFill>
-                  <a:srgbClr val="5B6B61"/>
+                  <a:srgbClr val="55677A"/>
                 </a:solidFill>
                 <a:latin typeface="Arial"/>
               </a:rPr>
@@ -5708,7 +5708,7 @@
           </a:solidFill>
           <a:ln w="12700">
             <a:solidFill>
-              <a:srgbClr val="6B7A70"/>
+              <a:srgbClr val="6B7A89"/>
             </a:solidFill>
             <a:prstDash val="dash"/>
           </a:ln>
@@ -5736,7 +5736,7 @@
             <a:r>
               <a:rPr sz="1100" b="1" i="0">
                 <a:solidFill>
-                  <a:srgbClr val="5B6B61"/>
+                  <a:srgbClr val="55677A"/>
                 </a:solidFill>
                 <a:latin typeface="Arial"/>
               </a:rPr>
@@ -5748,7 +5748,7 @@
             <a:r>
               <a:rPr sz="1100" b="0" i="0">
                 <a:solidFill>
-                  <a:srgbClr val="5B6B61"/>
+                  <a:srgbClr val="55677A"/>
                 </a:solidFill>
                 <a:latin typeface="Arial"/>
               </a:rPr>
@@ -5772,11 +5772,11 @@
             <a:avLst/>
           </a:prstGeom>
           <a:solidFill>
-            <a:srgbClr val="E8F0EA"/>
+            <a:srgbClr val="E5EEF6"/>
           </a:solidFill>
           <a:ln w="22225">
             <a:solidFill>
-              <a:srgbClr val="1B4D2E"/>
+              <a:srgbClr val="1B4F72"/>
             </a:solidFill>
           </a:ln>
           <a:effectLst/>
@@ -5803,7 +5803,7 @@
             <a:r>
               <a:rPr sz="1014" b="1" i="0">
                 <a:solidFill>
-                  <a:srgbClr val="1E2A22"/>
+                  <a:srgbClr val="1B2733"/>
                 </a:solidFill>
                 <a:latin typeface="Arial"/>
               </a:rPr>
@@ -5812,7 +5812,7 @@
             <a:r>
               <a:rPr sz="1300" b="1" i="0">
                 <a:solidFill>
-                  <a:srgbClr val="1E2A22"/>
+                  <a:srgbClr val="1B2733"/>
                 </a:solidFill>
                 <a:latin typeface="Arial"/>
               </a:rPr>
@@ -5836,11 +5836,11 @@
             <a:avLst/>
           </a:prstGeom>
           <a:solidFill>
-            <a:srgbClr val="E8F0EA"/>
+            <a:srgbClr val="E5EEF6"/>
           </a:solidFill>
           <a:ln w="22225">
             <a:solidFill>
-              <a:srgbClr val="1B4D2E"/>
+              <a:srgbClr val="1B4F72"/>
             </a:solidFill>
           </a:ln>
           <a:effectLst/>
@@ -5867,7 +5867,7 @@
             <a:r>
               <a:rPr sz="1014" b="1" i="0">
                 <a:solidFill>
-                  <a:srgbClr val="1E2A22"/>
+                  <a:srgbClr val="1B2733"/>
                 </a:solidFill>
                 <a:latin typeface="Arial"/>
               </a:rPr>
@@ -5876,7 +5876,7 @@
             <a:r>
               <a:rPr sz="1300" b="1" i="0">
                 <a:solidFill>
-                  <a:srgbClr val="1E2A22"/>
+                  <a:srgbClr val="1B2733"/>
                 </a:solidFill>
                 <a:latin typeface="Arial"/>
               </a:rPr>
@@ -5900,11 +5900,11 @@
             <a:avLst/>
           </a:prstGeom>
           <a:solidFill>
-            <a:srgbClr val="E8F0EA"/>
+            <a:srgbClr val="E5EEF6"/>
           </a:solidFill>
           <a:ln w="22225">
             <a:solidFill>
-              <a:srgbClr val="1B4D2E"/>
+              <a:srgbClr val="1B4F72"/>
             </a:solidFill>
           </a:ln>
           <a:effectLst/>
@@ -5931,7 +5931,7 @@
             <a:r>
               <a:rPr sz="1014" b="1" i="0">
                 <a:solidFill>
-                  <a:srgbClr val="1E2A22"/>
+                  <a:srgbClr val="1B2733"/>
                 </a:solidFill>
                 <a:latin typeface="Arial"/>
               </a:rPr>
@@ -5940,7 +5940,7 @@
             <a:r>
               <a:rPr sz="1300" b="1" i="0">
                 <a:solidFill>
-                  <a:srgbClr val="1E2A22"/>
+                  <a:srgbClr val="1B2733"/>
                 </a:solidFill>
                 <a:latin typeface="Arial"/>
               </a:rPr>
@@ -5964,11 +5964,11 @@
             <a:avLst/>
           </a:prstGeom>
           <a:solidFill>
-            <a:srgbClr val="F4F8F5"/>
+            <a:srgbClr val="F3F7FA"/>
           </a:solidFill>
           <a:ln w="12700">
             <a:solidFill>
-              <a:srgbClr val="7FA48C"/>
+              <a:srgbClr val="7B9BB5"/>
             </a:solidFill>
           </a:ln>
           <a:effectLst/>
@@ -5995,7 +5995,7 @@
             <a:r>
               <a:rPr sz="916" b="1" i="0">
                 <a:solidFill>
-                  <a:srgbClr val="1E2A22"/>
+                  <a:srgbClr val="1B2733"/>
                 </a:solidFill>
                 <a:latin typeface="Arial"/>
               </a:rPr>
@@ -6004,7 +6004,7 @@
             <a:r>
               <a:rPr sz="1175" b="0" i="0">
                 <a:solidFill>
-                  <a:srgbClr val="1E2A22"/>
+                  <a:srgbClr val="1B2733"/>
                 </a:solidFill>
                 <a:latin typeface="Arial"/>
               </a:rPr>
@@ -6028,11 +6028,11 @@
             <a:avLst/>
           </a:prstGeom>
           <a:solidFill>
-            <a:srgbClr val="F4F8F5"/>
+            <a:srgbClr val="F3F7FA"/>
           </a:solidFill>
           <a:ln w="12700">
             <a:solidFill>
-              <a:srgbClr val="7FA48C"/>
+              <a:srgbClr val="7B9BB5"/>
             </a:solidFill>
           </a:ln>
           <a:effectLst/>
@@ -6059,7 +6059,7 @@
             <a:r>
               <a:rPr sz="916" b="1" i="0">
                 <a:solidFill>
-                  <a:srgbClr val="1E2A22"/>
+                  <a:srgbClr val="1B2733"/>
                 </a:solidFill>
                 <a:latin typeface="Arial"/>
               </a:rPr>
@@ -6068,7 +6068,7 @@
             <a:r>
               <a:rPr sz="1175" b="0" i="0">
                 <a:solidFill>
-                  <a:srgbClr val="1E2A22"/>
+                  <a:srgbClr val="1B2733"/>
                 </a:solidFill>
                 <a:latin typeface="Arial"/>
               </a:rPr>
@@ -6092,11 +6092,11 @@
             <a:avLst/>
           </a:prstGeom>
           <a:solidFill>
-            <a:srgbClr val="F4F8F5"/>
+            <a:srgbClr val="F3F7FA"/>
           </a:solidFill>
           <a:ln w="12700">
             <a:solidFill>
-              <a:srgbClr val="7FA48C"/>
+              <a:srgbClr val="7B9BB5"/>
             </a:solidFill>
           </a:ln>
           <a:effectLst/>
@@ -6123,7 +6123,7 @@
             <a:r>
               <a:rPr sz="916" b="1" i="0">
                 <a:solidFill>
-                  <a:srgbClr val="1E2A22"/>
+                  <a:srgbClr val="1B2733"/>
                 </a:solidFill>
                 <a:latin typeface="Arial"/>
               </a:rPr>
@@ -6132,7 +6132,7 @@
             <a:r>
               <a:rPr sz="1175" b="0" i="0">
                 <a:solidFill>
-                  <a:srgbClr val="1E2A22"/>
+                  <a:srgbClr val="1B2733"/>
                 </a:solidFill>
                 <a:latin typeface="Arial"/>
               </a:rPr>
@@ -6156,11 +6156,11 @@
             <a:avLst/>
           </a:prstGeom>
           <a:solidFill>
-            <a:srgbClr val="F4F8F5"/>
+            <a:srgbClr val="F3F7FA"/>
           </a:solidFill>
           <a:ln w="12700">
             <a:solidFill>
-              <a:srgbClr val="7FA48C"/>
+              <a:srgbClr val="7B9BB5"/>
             </a:solidFill>
           </a:ln>
           <a:effectLst/>
@@ -6187,7 +6187,7 @@
             <a:r>
               <a:rPr sz="916" b="1" i="0">
                 <a:solidFill>
-                  <a:srgbClr val="1E2A22"/>
+                  <a:srgbClr val="1B2733"/>
                 </a:solidFill>
                 <a:latin typeface="Arial"/>
               </a:rPr>
@@ -6196,7 +6196,7 @@
             <a:r>
               <a:rPr sz="1175" b="0" i="0">
                 <a:solidFill>
-                  <a:srgbClr val="1E2A22"/>
+                  <a:srgbClr val="1B2733"/>
                 </a:solidFill>
                 <a:latin typeface="Arial"/>
               </a:rPr>
@@ -6220,11 +6220,11 @@
             <a:avLst/>
           </a:prstGeom>
           <a:solidFill>
-            <a:srgbClr val="F4F8F5"/>
+            <a:srgbClr val="F3F7FA"/>
           </a:solidFill>
           <a:ln w="12700">
             <a:solidFill>
-              <a:srgbClr val="7FA48C"/>
+              <a:srgbClr val="7B9BB5"/>
             </a:solidFill>
           </a:ln>
           <a:effectLst/>
@@ -6251,7 +6251,7 @@
             <a:r>
               <a:rPr sz="916" b="1" i="0">
                 <a:solidFill>
-                  <a:srgbClr val="1E2A22"/>
+                  <a:srgbClr val="1B2733"/>
                 </a:solidFill>
                 <a:latin typeface="Arial"/>
               </a:rPr>
@@ -6260,7 +6260,7 @@
             <a:r>
               <a:rPr sz="1175" b="0" i="0">
                 <a:solidFill>
-                  <a:srgbClr val="1E2A22"/>
+                  <a:srgbClr val="1B2733"/>
                 </a:solidFill>
                 <a:latin typeface="Arial"/>
               </a:rPr>
@@ -6284,11 +6284,11 @@
             <a:avLst/>
           </a:prstGeom>
           <a:solidFill>
-            <a:srgbClr val="F4F8F5"/>
+            <a:srgbClr val="F3F7FA"/>
           </a:solidFill>
           <a:ln w="12700">
             <a:solidFill>
-              <a:srgbClr val="7FA48C"/>
+              <a:srgbClr val="7B9BB5"/>
             </a:solidFill>
           </a:ln>
           <a:effectLst/>
@@ -6315,7 +6315,7 @@
             <a:r>
               <a:rPr sz="916" b="1" i="0">
                 <a:solidFill>
-                  <a:srgbClr val="1E2A22"/>
+                  <a:srgbClr val="1B2733"/>
                 </a:solidFill>
                 <a:latin typeface="Arial"/>
               </a:rPr>
@@ -6324,7 +6324,7 @@
             <a:r>
               <a:rPr sz="1175" b="0" i="0">
                 <a:solidFill>
-                  <a:srgbClr val="1E2A22"/>
+                  <a:srgbClr val="1B2733"/>
                 </a:solidFill>
                 <a:latin typeface="Arial"/>
               </a:rPr>
@@ -6348,11 +6348,11 @@
             <a:avLst/>
           </a:prstGeom>
           <a:solidFill>
-            <a:srgbClr val="F4F8F5"/>
+            <a:srgbClr val="F3F7FA"/>
           </a:solidFill>
           <a:ln w="12700">
             <a:solidFill>
-              <a:srgbClr val="7FA48C"/>
+              <a:srgbClr val="7B9BB5"/>
             </a:solidFill>
           </a:ln>
           <a:effectLst/>
@@ -6379,7 +6379,7 @@
             <a:r>
               <a:rPr sz="916" b="1" i="0">
                 <a:solidFill>
-                  <a:srgbClr val="1E2A22"/>
+                  <a:srgbClr val="1B2733"/>
                 </a:solidFill>
                 <a:latin typeface="Arial"/>
               </a:rPr>
@@ -6388,7 +6388,7 @@
             <a:r>
               <a:rPr sz="1175" b="0" i="0">
                 <a:solidFill>
-                  <a:srgbClr val="1E2A22"/>
+                  <a:srgbClr val="1B2733"/>
                 </a:solidFill>
                 <a:latin typeface="Arial"/>
               </a:rPr>
@@ -6412,11 +6412,11 @@
             <a:avLst/>
           </a:prstGeom>
           <a:solidFill>
-            <a:srgbClr val="F4F8F5"/>
+            <a:srgbClr val="F3F7FA"/>
           </a:solidFill>
           <a:ln w="12700">
             <a:solidFill>
-              <a:srgbClr val="7FA48C"/>
+              <a:srgbClr val="7B9BB5"/>
             </a:solidFill>
           </a:ln>
           <a:effectLst/>
@@ -6443,7 +6443,7 @@
             <a:r>
               <a:rPr sz="916" b="1" i="0">
                 <a:solidFill>
-                  <a:srgbClr val="1E2A22"/>
+                  <a:srgbClr val="1B2733"/>
                 </a:solidFill>
                 <a:latin typeface="Arial"/>
               </a:rPr>
@@ -6452,7 +6452,7 @@
             <a:r>
               <a:rPr sz="1175" b="0" i="0">
                 <a:solidFill>
-                  <a:srgbClr val="1E2A22"/>
+                  <a:srgbClr val="1B2733"/>
                 </a:solidFill>
                 <a:latin typeface="Arial"/>
               </a:rPr>
@@ -6476,11 +6476,11 @@
             <a:avLst/>
           </a:prstGeom>
           <a:solidFill>
-            <a:srgbClr val="F4F8F5"/>
+            <a:srgbClr val="F3F7FA"/>
           </a:solidFill>
           <a:ln w="12700">
             <a:solidFill>
-              <a:srgbClr val="7FA48C"/>
+              <a:srgbClr val="7B9BB5"/>
             </a:solidFill>
           </a:ln>
           <a:effectLst/>
@@ -6507,7 +6507,7 @@
             <a:r>
               <a:rPr sz="916" b="1" i="0">
                 <a:solidFill>
-                  <a:srgbClr val="1E2A22"/>
+                  <a:srgbClr val="1B2733"/>
                 </a:solidFill>
                 <a:latin typeface="Arial"/>
               </a:rPr>
@@ -6516,7 +6516,7 @@
             <a:r>
               <a:rPr sz="1175" b="0" i="0">
                 <a:solidFill>
-                  <a:srgbClr val="1E2A22"/>
+                  <a:srgbClr val="1B2733"/>
                 </a:solidFill>
                 <a:latin typeface="Arial"/>
               </a:rPr>
@@ -6540,11 +6540,11 @@
             <a:avLst/>
           </a:prstGeom>
           <a:solidFill>
-            <a:srgbClr val="F4F8F5"/>
+            <a:srgbClr val="F3F7FA"/>
           </a:solidFill>
           <a:ln w="12700">
             <a:solidFill>
-              <a:srgbClr val="7FA48C"/>
+              <a:srgbClr val="7B9BB5"/>
             </a:solidFill>
           </a:ln>
           <a:effectLst/>
@@ -6571,7 +6571,7 @@
             <a:r>
               <a:rPr sz="916" b="1" i="0">
                 <a:solidFill>
-                  <a:srgbClr val="1E2A22"/>
+                  <a:srgbClr val="1B2733"/>
                 </a:solidFill>
                 <a:latin typeface="Arial"/>
               </a:rPr>
@@ -6580,7 +6580,7 @@
             <a:r>
               <a:rPr sz="1175" b="0" i="0">
                 <a:solidFill>
-                  <a:srgbClr val="1E2A22"/>
+                  <a:srgbClr val="1B2733"/>
                 </a:solidFill>
                 <a:latin typeface="Arial"/>
               </a:rPr>
@@ -6661,7 +6661,7 @@
             <a:r>
               <a:rPr sz="750" b="0" i="0">
                 <a:solidFill>
-                  <a:srgbClr val="5B6B61"/>
+                  <a:srgbClr val="55677A"/>
                 </a:solidFill>
                 <a:latin typeface="Arial"/>
               </a:rPr>
@@ -6742,7 +6742,7 @@
             <a:r>
               <a:rPr sz="750" b="0" i="0">
                 <a:solidFill>
-                  <a:srgbClr val="5B6B61"/>
+                  <a:srgbClr val="55677A"/>
                 </a:solidFill>
                 <a:latin typeface="Arial"/>
               </a:rPr>
@@ -6823,7 +6823,7 @@
             <a:r>
               <a:rPr sz="750" b="0" i="0">
                 <a:solidFill>
-                  <a:srgbClr val="5B6B61"/>
+                  <a:srgbClr val="55677A"/>
                 </a:solidFill>
                 <a:latin typeface="Arial"/>
               </a:rPr>
@@ -6847,11 +6847,11 @@
             <a:avLst/>
           </a:prstGeom>
           <a:solidFill>
-            <a:srgbClr val="1B4D2E"/>
+            <a:srgbClr val="1B4F72"/>
           </a:solidFill>
           <a:ln>
             <a:solidFill>
-              <a:srgbClr val="1B4D2E"/>
+              <a:srgbClr val="1B4F72"/>
             </a:solidFill>
           </a:ln>
           <a:effectLst/>
@@ -6904,7 +6904,7 @@
             <a:r>
               <a:rPr sz="750" b="0" i="0">
                 <a:solidFill>
-                  <a:srgbClr val="5B6B61"/>
+                  <a:srgbClr val="55677A"/>
                 </a:solidFill>
                 <a:latin typeface="Arial"/>
               </a:rPr>
@@ -6928,11 +6928,11 @@
             <a:avLst/>
           </a:prstGeom>
           <a:solidFill>
-            <a:srgbClr val="E8F0EA"/>
+            <a:srgbClr val="E5EEF6"/>
           </a:solidFill>
           <a:ln>
             <a:solidFill>
-              <a:srgbClr val="1B4D2E"/>
+              <a:srgbClr val="1B4F72"/>
             </a:solidFill>
           </a:ln>
           <a:effectLst/>
@@ -6985,7 +6985,7 @@
             <a:r>
               <a:rPr sz="750" b="0" i="0">
                 <a:solidFill>
-                  <a:srgbClr val="5B6B61"/>
+                  <a:srgbClr val="55677A"/>
                 </a:solidFill>
                 <a:latin typeface="Arial"/>
               </a:rPr>
@@ -7009,11 +7009,11 @@
             <a:avLst/>
           </a:prstGeom>
           <a:solidFill>
-            <a:srgbClr val="F4F8F5"/>
+            <a:srgbClr val="F3F7FA"/>
           </a:solidFill>
           <a:ln>
             <a:solidFill>
-              <a:srgbClr val="7FA48C"/>
+              <a:srgbClr val="7B9BB5"/>
             </a:solidFill>
           </a:ln>
           <a:effectLst/>
@@ -7066,7 +7066,7 @@
             <a:r>
               <a:rPr sz="750" b="0" i="0">
                 <a:solidFill>
-                  <a:srgbClr val="5B6B61"/>
+                  <a:srgbClr val="55677A"/>
                 </a:solidFill>
                 <a:latin typeface="Arial"/>
               </a:rPr>
@@ -7094,7 +7094,7 @@
           </a:solidFill>
           <a:ln>
             <a:solidFill>
-              <a:srgbClr val="6B7A70"/>
+              <a:srgbClr val="6B7A89"/>
             </a:solidFill>
             <a:prstDash val="dash"/>
           </a:ln>
@@ -7148,7 +7148,7 @@
             <a:r>
               <a:rPr sz="750" b="0" i="0">
                 <a:solidFill>
-                  <a:srgbClr val="5B6B61"/>
+                  <a:srgbClr val="55677A"/>
                 </a:solidFill>
                 <a:latin typeface="Arial"/>
               </a:rPr>
@@ -7194,7 +7194,7 @@
           </a:prstGeom>
           <a:ln w="15875">
             <a:solidFill>
-              <a:srgbClr val="4A5A50"/>
+              <a:srgbClr val="4A5867"/>
             </a:solidFill>
             <a:headEnd type="triangle" w="med" len="med"/>
           </a:ln>
@@ -7233,7 +7233,7 @@
           </a:prstGeom>
           <a:ln w="15875">
             <a:solidFill>
-              <a:srgbClr val="4A5A50"/>
+              <a:srgbClr val="4A5867"/>
             </a:solidFill>
             <a:headEnd type="triangle" w="med" len="med"/>
           </a:ln>
@@ -7272,7 +7272,7 @@
           </a:prstGeom>
           <a:ln w="15875">
             <a:solidFill>
-              <a:srgbClr val="4A5A50"/>
+              <a:srgbClr val="4A5867"/>
             </a:solidFill>
             <a:headEnd type="triangle" w="med" len="med"/>
           </a:ln>
@@ -7311,7 +7311,7 @@
           </a:prstGeom>
           <a:ln w="15875">
             <a:solidFill>
-              <a:srgbClr val="4A5A50"/>
+              <a:srgbClr val="4A5867"/>
             </a:solidFill>
             <a:headEnd type="triangle" w="med" len="med"/>
           </a:ln>
@@ -7350,7 +7350,7 @@
           </a:prstGeom>
           <a:ln w="15875">
             <a:solidFill>
-              <a:srgbClr val="4A5A50"/>
+              <a:srgbClr val="4A5867"/>
             </a:solidFill>
             <a:headEnd type="triangle" w="med" len="med"/>
           </a:ln>
@@ -7389,7 +7389,7 @@
           </a:prstGeom>
           <a:ln w="15875">
             <a:solidFill>
-              <a:srgbClr val="4A5A50"/>
+              <a:srgbClr val="4A5867"/>
             </a:solidFill>
             <a:headEnd type="triangle" w="med" len="med"/>
           </a:ln>
@@ -7428,7 +7428,7 @@
           </a:prstGeom>
           <a:ln w="15875">
             <a:solidFill>
-              <a:srgbClr val="4A5A50"/>
+              <a:srgbClr val="4A5867"/>
             </a:solidFill>
             <a:headEnd type="triangle" w="med" len="med"/>
           </a:ln>
@@ -7467,7 +7467,7 @@
           </a:prstGeom>
           <a:ln w="15875">
             <a:solidFill>
-              <a:srgbClr val="4A5A50"/>
+              <a:srgbClr val="4A5867"/>
             </a:solidFill>
             <a:headEnd type="triangle" w="med" len="med"/>
           </a:ln>
@@ -7506,7 +7506,7 @@
           </a:prstGeom>
           <a:ln w="15875">
             <a:solidFill>
-              <a:srgbClr val="4A5A50"/>
+              <a:srgbClr val="4A5867"/>
             </a:solidFill>
             <a:headEnd type="triangle" w="med" len="med"/>
           </a:ln>
@@ -7545,7 +7545,7 @@
           </a:prstGeom>
           <a:ln w="15875">
             <a:solidFill>
-              <a:srgbClr val="4A5A50"/>
+              <a:srgbClr val="4A5867"/>
             </a:solidFill>
             <a:headEnd type="triangle" w="med" len="med"/>
           </a:ln>
@@ -7584,7 +7584,7 @@
           </a:prstGeom>
           <a:ln w="15875">
             <a:solidFill>
-              <a:srgbClr val="4A5A50"/>
+              <a:srgbClr val="4A5867"/>
             </a:solidFill>
             <a:headEnd type="triangle" w="med" len="med"/>
           </a:ln>
@@ -7623,7 +7623,7 @@
           </a:prstGeom>
           <a:ln w="15875">
             <a:solidFill>
-              <a:srgbClr val="4A5A50"/>
+              <a:srgbClr val="4A5867"/>
             </a:solidFill>
             <a:headEnd type="triangle" w="med" len="med"/>
           </a:ln>
@@ -7662,7 +7662,7 @@
           </a:prstGeom>
           <a:ln w="15875">
             <a:solidFill>
-              <a:srgbClr val="4A5A50"/>
+              <a:srgbClr val="4A5867"/>
             </a:solidFill>
             <a:headEnd type="triangle" w="med" len="med"/>
           </a:ln>
@@ -7701,7 +7701,7 @@
           </a:prstGeom>
           <a:ln w="15875">
             <a:solidFill>
-              <a:srgbClr val="4A5A50"/>
+              <a:srgbClr val="4A5867"/>
             </a:solidFill>
           </a:ln>
         </p:spPr>
@@ -7739,7 +7739,7 @@
           </a:prstGeom>
           <a:ln w="15875">
             <a:solidFill>
-              <a:srgbClr val="4A5A50"/>
+              <a:srgbClr val="4A5867"/>
             </a:solidFill>
           </a:ln>
         </p:spPr>
@@ -7777,7 +7777,7 @@
           </a:prstGeom>
           <a:ln w="15875">
             <a:solidFill>
-              <a:srgbClr val="4A5A50"/>
+              <a:srgbClr val="4A5867"/>
             </a:solidFill>
           </a:ln>
         </p:spPr>
@@ -7815,7 +7815,7 @@
           </a:prstGeom>
           <a:ln w="15875">
             <a:solidFill>
-              <a:srgbClr val="4A5A50"/>
+              <a:srgbClr val="4A5867"/>
             </a:solidFill>
           </a:ln>
         </p:spPr>
@@ -7853,7 +7853,7 @@
           </a:prstGeom>
           <a:ln w="15875">
             <a:solidFill>
-              <a:srgbClr val="4A5A50"/>
+              <a:srgbClr val="4A5867"/>
             </a:solidFill>
           </a:ln>
         </p:spPr>
@@ -7891,7 +7891,7 @@
           </a:prstGeom>
           <a:ln w="15875">
             <a:solidFill>
-              <a:srgbClr val="4A5A50"/>
+              <a:srgbClr val="4A5867"/>
             </a:solidFill>
           </a:ln>
         </p:spPr>
@@ -7929,7 +7929,7 @@
           </a:prstGeom>
           <a:ln w="15875">
             <a:solidFill>
-              <a:srgbClr val="4A5A50"/>
+              <a:srgbClr val="4A5867"/>
             </a:solidFill>
           </a:ln>
         </p:spPr>
@@ -7967,7 +7967,7 @@
           </a:prstGeom>
           <a:ln w="15875">
             <a:solidFill>
-              <a:srgbClr val="4A5A50"/>
+              <a:srgbClr val="4A5867"/>
             </a:solidFill>
           </a:ln>
         </p:spPr>
@@ -8005,7 +8005,7 @@
           </a:prstGeom>
           <a:ln w="15875">
             <a:solidFill>
-              <a:srgbClr val="4A5A50"/>
+              <a:srgbClr val="4A5867"/>
             </a:solidFill>
           </a:ln>
         </p:spPr>
@@ -8043,7 +8043,7 @@
           </a:prstGeom>
           <a:ln w="15875">
             <a:solidFill>
-              <a:srgbClr val="4A5A50"/>
+              <a:srgbClr val="4A5867"/>
             </a:solidFill>
           </a:ln>
         </p:spPr>
@@ -8081,7 +8081,7 @@
           </a:prstGeom>
           <a:ln w="15875">
             <a:solidFill>
-              <a:srgbClr val="4A5A50"/>
+              <a:srgbClr val="4A5867"/>
             </a:solidFill>
             <a:headEnd type="triangle" w="med" len="med"/>
           </a:ln>
@@ -8120,7 +8120,7 @@
           </a:prstGeom>
           <a:ln w="15875">
             <a:solidFill>
-              <a:srgbClr val="4A5A50"/>
+              <a:srgbClr val="4A5867"/>
             </a:solidFill>
             <a:headEnd type="triangle" w="med" len="med"/>
           </a:ln>
@@ -8159,7 +8159,7 @@
           </a:prstGeom>
           <a:ln w="15875">
             <a:solidFill>
-              <a:srgbClr val="4A5A50"/>
+              <a:srgbClr val="4A5867"/>
             </a:solidFill>
             <a:headEnd type="triangle" w="med" len="med"/>
           </a:ln>
@@ -8198,7 +8198,7 @@
           </a:prstGeom>
           <a:ln w="15875">
             <a:solidFill>
-              <a:srgbClr val="6B7A70"/>
+              <a:srgbClr val="6B7A89"/>
             </a:solidFill>
             <a:prstDash val="dash"/>
             <a:tailEnd type="triangle"/>
@@ -8238,7 +8238,7 @@
           </a:prstGeom>
           <a:ln w="15875">
             <a:solidFill>
-              <a:srgbClr val="6B7A70"/>
+              <a:srgbClr val="6B7A89"/>
             </a:solidFill>
             <a:prstDash val="dash"/>
             <a:tailEnd type="triangle"/>
@@ -8274,7 +8274,7 @@
             <a:avLst/>
           </a:prstGeom>
           <a:solidFill>
-            <a:srgbClr val="1B4D2E"/>
+            <a:srgbClr val="1B4F72"/>
           </a:solidFill>
           <a:ln>
             <a:noFill/>
@@ -8362,7 +8362,7 @@
             <a:r>
               <a:rPr sz="750" b="0" i="0">
                 <a:solidFill>
-                  <a:srgbClr val="5B6B61"/>
+                  <a:srgbClr val="55677A"/>
                 </a:solidFill>
                 <a:latin typeface="Arial"/>
               </a:rPr>
@@ -8474,7 +8474,7 @@
             <a:r>
               <a:rPr sz="955" b="1" i="0">
                 <a:solidFill>
-                  <a:srgbClr val="1E2A22"/>
+                  <a:srgbClr val="1B2733"/>
                 </a:solidFill>
                 <a:latin typeface="Arial"/>
               </a:rPr>
@@ -8483,7 +8483,7 @@
             <a:r>
               <a:rPr sz="1225" b="0" i="0">
                 <a:solidFill>
-                  <a:srgbClr val="1E2A22"/>
+                  <a:srgbClr val="1B2733"/>
                 </a:solidFill>
                 <a:latin typeface="Arial"/>
               </a:rPr>
@@ -8538,7 +8538,7 @@
             <a:r>
               <a:rPr sz="955" b="1" i="0">
                 <a:solidFill>
-                  <a:srgbClr val="1E2A22"/>
+                  <a:srgbClr val="1B2733"/>
                 </a:solidFill>
                 <a:latin typeface="Arial"/>
               </a:rPr>
@@ -8547,7 +8547,7 @@
             <a:r>
               <a:rPr sz="1225" b="0" i="0">
                 <a:solidFill>
-                  <a:srgbClr val="1E2A22"/>
+                  <a:srgbClr val="1B2733"/>
                 </a:solidFill>
                 <a:latin typeface="Arial"/>
               </a:rPr>
@@ -8602,7 +8602,7 @@
             <a:r>
               <a:rPr sz="955" b="1" i="0">
                 <a:solidFill>
-                  <a:srgbClr val="1E2A22"/>
+                  <a:srgbClr val="1B2733"/>
                 </a:solidFill>
                 <a:latin typeface="Arial"/>
               </a:rPr>
@@ -8611,7 +8611,7 @@
             <a:r>
               <a:rPr sz="1225" b="0" i="0">
                 <a:solidFill>
-                  <a:srgbClr val="1E2A22"/>
+                  <a:srgbClr val="1B2733"/>
                 </a:solidFill>
                 <a:latin typeface="Arial"/>
               </a:rPr>
@@ -8666,7 +8666,7 @@
             <a:r>
               <a:rPr sz="955" b="1" i="0">
                 <a:solidFill>
-                  <a:srgbClr val="1E2A22"/>
+                  <a:srgbClr val="1B2733"/>
                 </a:solidFill>
                 <a:latin typeface="Arial"/>
               </a:rPr>
@@ -8675,7 +8675,7 @@
             <a:r>
               <a:rPr sz="1225" b="0" i="0">
                 <a:solidFill>
-                  <a:srgbClr val="1E2A22"/>
+                  <a:srgbClr val="1B2733"/>
                 </a:solidFill>
                 <a:latin typeface="Arial"/>
               </a:rPr>
@@ -8730,7 +8730,7 @@
             <a:r>
               <a:rPr sz="1014" b="1" i="0">
                 <a:solidFill>
-                  <a:srgbClr val="1E2A22"/>
+                  <a:srgbClr val="1B2733"/>
                 </a:solidFill>
                 <a:latin typeface="Arial"/>
               </a:rPr>
@@ -8739,7 +8739,7 @@
             <a:r>
               <a:rPr sz="1300" b="1" i="0">
                 <a:solidFill>
-                  <a:srgbClr val="1E2A22"/>
+                  <a:srgbClr val="1B2733"/>
                 </a:solidFill>
                 <a:latin typeface="Arial"/>
               </a:rPr>
@@ -8794,7 +8794,7 @@
             <a:r>
               <a:rPr sz="1014" b="1" i="0">
                 <a:solidFill>
-                  <a:srgbClr val="1E2A22"/>
+                  <a:srgbClr val="1B2733"/>
                 </a:solidFill>
                 <a:latin typeface="Arial"/>
               </a:rPr>
@@ -8803,7 +8803,7 @@
             <a:r>
               <a:rPr sz="1300" b="1" i="0">
                 <a:solidFill>
-                  <a:srgbClr val="1E2A22"/>
+                  <a:srgbClr val="1B2733"/>
                 </a:solidFill>
                 <a:latin typeface="Arial"/>
               </a:rPr>
@@ -8858,7 +8858,7 @@
             <a:r>
               <a:rPr sz="1014" b="1" i="0">
                 <a:solidFill>
-                  <a:srgbClr val="1E2A22"/>
+                  <a:srgbClr val="1B2733"/>
                 </a:solidFill>
                 <a:latin typeface="Arial"/>
               </a:rPr>
@@ -8867,7 +8867,7 @@
             <a:r>
               <a:rPr sz="1300" b="1" i="0">
                 <a:solidFill>
-                  <a:srgbClr val="1E2A22"/>
+                  <a:srgbClr val="1B2733"/>
                 </a:solidFill>
                 <a:latin typeface="Arial"/>
               </a:rPr>
@@ -8893,11 +8893,11 @@
             </a:avLst>
           </a:prstGeom>
           <a:solidFill>
-            <a:srgbClr val="1B4D2E"/>
+            <a:srgbClr val="1B4F72"/>
           </a:solidFill>
           <a:ln w="12700">
             <a:solidFill>
-              <a:srgbClr val="1B4D2E"/>
+              <a:srgbClr val="1B4F72"/>
             </a:solidFill>
           </a:ln>
           <a:effectLst/>
@@ -8952,7 +8952,7 @@
           </a:solidFill>
           <a:ln w="12700">
             <a:solidFill>
-              <a:srgbClr val="6B7A70"/>
+              <a:srgbClr val="6B7A89"/>
             </a:solidFill>
             <a:prstDash val="dash"/>
           </a:ln>
@@ -8980,7 +8980,7 @@
             <a:r>
               <a:rPr sz="1100" b="1" i="0">
                 <a:solidFill>
-                  <a:srgbClr val="5B6B61"/>
+                  <a:srgbClr val="55677A"/>
                 </a:solidFill>
                 <a:latin typeface="Arial"/>
               </a:rPr>
@@ -8992,7 +8992,7 @@
             <a:r>
               <a:rPr sz="1100" b="0" i="0">
                 <a:solidFill>
-                  <a:srgbClr val="5B6B61"/>
+                  <a:srgbClr val="55677A"/>
                 </a:solidFill>
                 <a:latin typeface="Arial"/>
               </a:rPr>
@@ -9020,7 +9020,7 @@
           </a:solidFill>
           <a:ln w="12700">
             <a:solidFill>
-              <a:srgbClr val="6B7A70"/>
+              <a:srgbClr val="6B7A89"/>
             </a:solidFill>
             <a:prstDash val="dash"/>
           </a:ln>
@@ -9048,7 +9048,7 @@
             <a:r>
               <a:rPr sz="1100" b="1" i="0">
                 <a:solidFill>
-                  <a:srgbClr val="5B6B61"/>
+                  <a:srgbClr val="55677A"/>
                 </a:solidFill>
                 <a:latin typeface="Arial"/>
               </a:rPr>
@@ -9060,7 +9060,7 @@
             <a:r>
               <a:rPr sz="1100" b="0" i="0">
                 <a:solidFill>
-                  <a:srgbClr val="5B6B61"/>
+                  <a:srgbClr val="55677A"/>
                 </a:solidFill>
                 <a:latin typeface="Arial"/>
               </a:rPr>
@@ -9084,11 +9084,11 @@
             <a:avLst/>
           </a:prstGeom>
           <a:solidFill>
-            <a:srgbClr val="E8F0EA"/>
+            <a:srgbClr val="E5EEF6"/>
           </a:solidFill>
           <a:ln w="22225">
             <a:solidFill>
-              <a:srgbClr val="1B4D2E"/>
+              <a:srgbClr val="1B4F72"/>
             </a:solidFill>
           </a:ln>
           <a:effectLst/>
@@ -9115,7 +9115,7 @@
             <a:r>
               <a:rPr sz="1014" b="1" i="0">
                 <a:solidFill>
-                  <a:srgbClr val="1E2A22"/>
+                  <a:srgbClr val="1B2733"/>
                 </a:solidFill>
                 <a:latin typeface="Arial"/>
               </a:rPr>
@@ -9124,7 +9124,7 @@
             <a:r>
               <a:rPr sz="1300" b="1" i="0">
                 <a:solidFill>
-                  <a:srgbClr val="1E2A22"/>
+                  <a:srgbClr val="1B2733"/>
                 </a:solidFill>
                 <a:latin typeface="Arial"/>
               </a:rPr>
@@ -9148,11 +9148,11 @@
             <a:avLst/>
           </a:prstGeom>
           <a:solidFill>
-            <a:srgbClr val="E8F0EA"/>
+            <a:srgbClr val="E5EEF6"/>
           </a:solidFill>
           <a:ln w="22225">
             <a:solidFill>
-              <a:srgbClr val="1B4D2E"/>
+              <a:srgbClr val="1B4F72"/>
             </a:solidFill>
           </a:ln>
           <a:effectLst/>
@@ -9179,7 +9179,7 @@
             <a:r>
               <a:rPr sz="1014" b="1" i="0">
                 <a:solidFill>
-                  <a:srgbClr val="1E2A22"/>
+                  <a:srgbClr val="1B2733"/>
                 </a:solidFill>
                 <a:latin typeface="Arial"/>
               </a:rPr>
@@ -9188,7 +9188,7 @@
             <a:r>
               <a:rPr sz="1300" b="1" i="0">
                 <a:solidFill>
-                  <a:srgbClr val="1E2A22"/>
+                  <a:srgbClr val="1B2733"/>
                 </a:solidFill>
                 <a:latin typeface="Arial"/>
               </a:rPr>
@@ -9212,11 +9212,11 @@
             <a:avLst/>
           </a:prstGeom>
           <a:solidFill>
-            <a:srgbClr val="E8F0EA"/>
+            <a:srgbClr val="E5EEF6"/>
           </a:solidFill>
           <a:ln w="22225">
             <a:solidFill>
-              <a:srgbClr val="1B4D2E"/>
+              <a:srgbClr val="1B4F72"/>
             </a:solidFill>
           </a:ln>
           <a:effectLst/>
@@ -9243,7 +9243,7 @@
             <a:r>
               <a:rPr sz="1014" b="1" i="0">
                 <a:solidFill>
-                  <a:srgbClr val="1E2A22"/>
+                  <a:srgbClr val="1B2733"/>
                 </a:solidFill>
                 <a:latin typeface="Arial"/>
               </a:rPr>
@@ -9252,7 +9252,7 @@
             <a:r>
               <a:rPr sz="1300" b="1" i="0">
                 <a:solidFill>
-                  <a:srgbClr val="1E2A22"/>
+                  <a:srgbClr val="1B2733"/>
                 </a:solidFill>
                 <a:latin typeface="Arial"/>
               </a:rPr>
@@ -9276,11 +9276,11 @@
             <a:avLst/>
           </a:prstGeom>
           <a:solidFill>
-            <a:srgbClr val="F4F8F5"/>
+            <a:srgbClr val="F3F7FA"/>
           </a:solidFill>
           <a:ln w="12700">
             <a:solidFill>
-              <a:srgbClr val="7FA48C"/>
+              <a:srgbClr val="7B9BB5"/>
             </a:solidFill>
           </a:ln>
           <a:effectLst/>
@@ -9307,7 +9307,7 @@
             <a:r>
               <a:rPr sz="916" b="1" i="0">
                 <a:solidFill>
-                  <a:srgbClr val="1E2A22"/>
+                  <a:srgbClr val="1B2733"/>
                 </a:solidFill>
                 <a:latin typeface="Arial"/>
               </a:rPr>
@@ -9316,7 +9316,7 @@
             <a:r>
               <a:rPr sz="1175" b="0" i="0">
                 <a:solidFill>
-                  <a:srgbClr val="1E2A22"/>
+                  <a:srgbClr val="1B2733"/>
                 </a:solidFill>
                 <a:latin typeface="Arial"/>
               </a:rPr>
@@ -9340,11 +9340,11 @@
             <a:avLst/>
           </a:prstGeom>
           <a:solidFill>
-            <a:srgbClr val="F4F8F5"/>
+            <a:srgbClr val="F3F7FA"/>
           </a:solidFill>
           <a:ln w="12700">
             <a:solidFill>
-              <a:srgbClr val="7FA48C"/>
+              <a:srgbClr val="7B9BB5"/>
             </a:solidFill>
           </a:ln>
           <a:effectLst/>
@@ -9371,7 +9371,7 @@
             <a:r>
               <a:rPr sz="916" b="1" i="0">
                 <a:solidFill>
-                  <a:srgbClr val="1E2A22"/>
+                  <a:srgbClr val="1B2733"/>
                 </a:solidFill>
                 <a:latin typeface="Arial"/>
               </a:rPr>
@@ -9380,7 +9380,7 @@
             <a:r>
               <a:rPr sz="1175" b="0" i="0">
                 <a:solidFill>
-                  <a:srgbClr val="1E2A22"/>
+                  <a:srgbClr val="1B2733"/>
                 </a:solidFill>
                 <a:latin typeface="Arial"/>
               </a:rPr>
@@ -9404,11 +9404,11 @@
             <a:avLst/>
           </a:prstGeom>
           <a:solidFill>
-            <a:srgbClr val="F4F8F5"/>
+            <a:srgbClr val="F3F7FA"/>
           </a:solidFill>
           <a:ln w="12700">
             <a:solidFill>
-              <a:srgbClr val="7FA48C"/>
+              <a:srgbClr val="7B9BB5"/>
             </a:solidFill>
           </a:ln>
           <a:effectLst/>
@@ -9435,7 +9435,7 @@
             <a:r>
               <a:rPr sz="916" b="1" i="0">
                 <a:solidFill>
-                  <a:srgbClr val="1E2A22"/>
+                  <a:srgbClr val="1B2733"/>
                 </a:solidFill>
                 <a:latin typeface="Arial"/>
               </a:rPr>
@@ -9444,7 +9444,7 @@
             <a:r>
               <a:rPr sz="1175" b="0" i="0">
                 <a:solidFill>
-                  <a:srgbClr val="1E2A22"/>
+                  <a:srgbClr val="1B2733"/>
                 </a:solidFill>
                 <a:latin typeface="Arial"/>
               </a:rPr>
@@ -9468,11 +9468,11 @@
             <a:avLst/>
           </a:prstGeom>
           <a:solidFill>
-            <a:srgbClr val="F4F8F5"/>
+            <a:srgbClr val="F3F7FA"/>
           </a:solidFill>
           <a:ln w="12700">
             <a:solidFill>
-              <a:srgbClr val="7FA48C"/>
+              <a:srgbClr val="7B9BB5"/>
             </a:solidFill>
           </a:ln>
           <a:effectLst/>
@@ -9499,7 +9499,7 @@
             <a:r>
               <a:rPr sz="916" b="1" i="0">
                 <a:solidFill>
-                  <a:srgbClr val="1E2A22"/>
+                  <a:srgbClr val="1B2733"/>
                 </a:solidFill>
                 <a:latin typeface="Arial"/>
               </a:rPr>
@@ -9508,7 +9508,7 @@
             <a:r>
               <a:rPr sz="1175" b="0" i="0">
                 <a:solidFill>
-                  <a:srgbClr val="1E2A22"/>
+                  <a:srgbClr val="1B2733"/>
                 </a:solidFill>
                 <a:latin typeface="Arial"/>
               </a:rPr>
@@ -9532,11 +9532,11 @@
             <a:avLst/>
           </a:prstGeom>
           <a:solidFill>
-            <a:srgbClr val="F4F8F5"/>
+            <a:srgbClr val="F3F7FA"/>
           </a:solidFill>
           <a:ln w="12700">
             <a:solidFill>
-              <a:srgbClr val="7FA48C"/>
+              <a:srgbClr val="7B9BB5"/>
             </a:solidFill>
           </a:ln>
           <a:effectLst/>
@@ -9563,7 +9563,7 @@
             <a:r>
               <a:rPr sz="916" b="1" i="0">
                 <a:solidFill>
-                  <a:srgbClr val="1E2A22"/>
+                  <a:srgbClr val="1B2733"/>
                 </a:solidFill>
                 <a:latin typeface="Arial"/>
               </a:rPr>
@@ -9572,7 +9572,7 @@
             <a:r>
               <a:rPr sz="1175" b="0" i="0">
                 <a:solidFill>
-                  <a:srgbClr val="1E2A22"/>
+                  <a:srgbClr val="1B2733"/>
                 </a:solidFill>
                 <a:latin typeface="Arial"/>
               </a:rPr>
@@ -9596,11 +9596,11 @@
             <a:avLst/>
           </a:prstGeom>
           <a:solidFill>
-            <a:srgbClr val="F4F8F5"/>
+            <a:srgbClr val="F3F7FA"/>
           </a:solidFill>
           <a:ln w="12700">
             <a:solidFill>
-              <a:srgbClr val="7FA48C"/>
+              <a:srgbClr val="7B9BB5"/>
             </a:solidFill>
           </a:ln>
           <a:effectLst/>
@@ -9627,7 +9627,7 @@
             <a:r>
               <a:rPr sz="916" b="1" i="0">
                 <a:solidFill>
-                  <a:srgbClr val="1E2A22"/>
+                  <a:srgbClr val="1B2733"/>
                 </a:solidFill>
                 <a:latin typeface="Arial"/>
               </a:rPr>
@@ -9636,7 +9636,7 @@
             <a:r>
               <a:rPr sz="1175" b="0" i="0">
                 <a:solidFill>
-                  <a:srgbClr val="1E2A22"/>
+                  <a:srgbClr val="1B2733"/>
                 </a:solidFill>
                 <a:latin typeface="Arial"/>
               </a:rPr>
@@ -9660,11 +9660,11 @@
             <a:avLst/>
           </a:prstGeom>
           <a:solidFill>
-            <a:srgbClr val="F4F8F5"/>
+            <a:srgbClr val="F3F7FA"/>
           </a:solidFill>
           <a:ln w="12700">
             <a:solidFill>
-              <a:srgbClr val="7FA48C"/>
+              <a:srgbClr val="7B9BB5"/>
             </a:solidFill>
           </a:ln>
           <a:effectLst/>
@@ -9691,7 +9691,7 @@
             <a:r>
               <a:rPr sz="916" b="1" i="0">
                 <a:solidFill>
-                  <a:srgbClr val="1E2A22"/>
+                  <a:srgbClr val="1B2733"/>
                 </a:solidFill>
                 <a:latin typeface="Arial"/>
               </a:rPr>
@@ -9700,7 +9700,7 @@
             <a:r>
               <a:rPr sz="1175" b="0" i="0">
                 <a:solidFill>
-                  <a:srgbClr val="1E2A22"/>
+                  <a:srgbClr val="1B2733"/>
                 </a:solidFill>
                 <a:latin typeface="Arial"/>
               </a:rPr>
@@ -9724,11 +9724,11 @@
             <a:avLst/>
           </a:prstGeom>
           <a:solidFill>
-            <a:srgbClr val="F4F8F5"/>
+            <a:srgbClr val="F3F7FA"/>
           </a:solidFill>
           <a:ln w="12700">
             <a:solidFill>
-              <a:srgbClr val="7FA48C"/>
+              <a:srgbClr val="7B9BB5"/>
             </a:solidFill>
           </a:ln>
           <a:effectLst/>
@@ -9755,7 +9755,7 @@
             <a:r>
               <a:rPr sz="916" b="1" i="0">
                 <a:solidFill>
-                  <a:srgbClr val="1E2A22"/>
+                  <a:srgbClr val="1B2733"/>
                 </a:solidFill>
                 <a:latin typeface="Arial"/>
               </a:rPr>
@@ -9764,7 +9764,7 @@
             <a:r>
               <a:rPr sz="1175" b="0" i="0">
                 <a:solidFill>
-                  <a:srgbClr val="1E2A22"/>
+                  <a:srgbClr val="1B2733"/>
                 </a:solidFill>
                 <a:latin typeface="Arial"/>
               </a:rPr>
@@ -9788,11 +9788,11 @@
             <a:avLst/>
           </a:prstGeom>
           <a:solidFill>
-            <a:srgbClr val="F4F8F5"/>
+            <a:srgbClr val="F3F7FA"/>
           </a:solidFill>
           <a:ln w="12700">
             <a:solidFill>
-              <a:srgbClr val="7FA48C"/>
+              <a:srgbClr val="7B9BB5"/>
             </a:solidFill>
           </a:ln>
           <a:effectLst/>
@@ -9819,7 +9819,7 @@
             <a:r>
               <a:rPr sz="916" b="1" i="0">
                 <a:solidFill>
-                  <a:srgbClr val="1E2A22"/>
+                  <a:srgbClr val="1B2733"/>
                 </a:solidFill>
                 <a:latin typeface="Arial"/>
               </a:rPr>
@@ -9828,7 +9828,7 @@
             <a:r>
               <a:rPr sz="1175" b="0" i="0">
                 <a:solidFill>
-                  <a:srgbClr val="1E2A22"/>
+                  <a:srgbClr val="1B2733"/>
                 </a:solidFill>
                 <a:latin typeface="Arial"/>
               </a:rPr>
@@ -9852,11 +9852,11 @@
             <a:avLst/>
           </a:prstGeom>
           <a:solidFill>
-            <a:srgbClr val="F4F8F5"/>
+            <a:srgbClr val="F3F7FA"/>
           </a:solidFill>
           <a:ln w="12700">
             <a:solidFill>
-              <a:srgbClr val="7FA48C"/>
+              <a:srgbClr val="7B9BB5"/>
             </a:solidFill>
           </a:ln>
           <a:effectLst/>
@@ -9883,7 +9883,7 @@
             <a:r>
               <a:rPr sz="916" b="1" i="0">
                 <a:solidFill>
-                  <a:srgbClr val="1E2A22"/>
+                  <a:srgbClr val="1B2733"/>
                 </a:solidFill>
                 <a:latin typeface="Arial"/>
               </a:rPr>
@@ -9892,7 +9892,7 @@
             <a:r>
               <a:rPr sz="1175" b="0" i="0">
                 <a:solidFill>
-                  <a:srgbClr val="1E2A22"/>
+                  <a:srgbClr val="1B2733"/>
                 </a:solidFill>
                 <a:latin typeface="Arial"/>
               </a:rPr>
@@ -9973,7 +9973,7 @@
             <a:r>
               <a:rPr sz="750" b="0" i="0">
                 <a:solidFill>
-                  <a:srgbClr val="5B6B61"/>
+                  <a:srgbClr val="55677A"/>
                 </a:solidFill>
                 <a:latin typeface="Arial"/>
               </a:rPr>
@@ -10054,7 +10054,7 @@
             <a:r>
               <a:rPr sz="750" b="0" i="0">
                 <a:solidFill>
-                  <a:srgbClr val="5B6B61"/>
+                  <a:srgbClr val="55677A"/>
                 </a:solidFill>
                 <a:latin typeface="Arial"/>
               </a:rPr>
@@ -10135,7 +10135,7 @@
             <a:r>
               <a:rPr sz="750" b="0" i="0">
                 <a:solidFill>
-                  <a:srgbClr val="5B6B61"/>
+                  <a:srgbClr val="55677A"/>
                 </a:solidFill>
                 <a:latin typeface="Arial"/>
               </a:rPr>
@@ -10159,11 +10159,11 @@
             <a:avLst/>
           </a:prstGeom>
           <a:solidFill>
-            <a:srgbClr val="1B4D2E"/>
+            <a:srgbClr val="1B4F72"/>
           </a:solidFill>
           <a:ln>
             <a:solidFill>
-              <a:srgbClr val="1B4D2E"/>
+              <a:srgbClr val="1B4F72"/>
             </a:solidFill>
           </a:ln>
           <a:effectLst/>
@@ -10216,7 +10216,7 @@
             <a:r>
               <a:rPr sz="750" b="0" i="0">
                 <a:solidFill>
-                  <a:srgbClr val="5B6B61"/>
+                  <a:srgbClr val="55677A"/>
                 </a:solidFill>
                 <a:latin typeface="Arial"/>
               </a:rPr>
@@ -10240,11 +10240,11 @@
             <a:avLst/>
           </a:prstGeom>
           <a:solidFill>
-            <a:srgbClr val="E8F0EA"/>
+            <a:srgbClr val="E5EEF6"/>
           </a:solidFill>
           <a:ln>
             <a:solidFill>
-              <a:srgbClr val="1B4D2E"/>
+              <a:srgbClr val="1B4F72"/>
             </a:solidFill>
           </a:ln>
           <a:effectLst/>
@@ -10297,7 +10297,7 @@
             <a:r>
               <a:rPr sz="750" b="0" i="0">
                 <a:solidFill>
-                  <a:srgbClr val="5B6B61"/>
+                  <a:srgbClr val="55677A"/>
                 </a:solidFill>
                 <a:latin typeface="Arial"/>
               </a:rPr>
@@ -10321,11 +10321,11 @@
             <a:avLst/>
           </a:prstGeom>
           <a:solidFill>
-            <a:srgbClr val="F4F8F5"/>
+            <a:srgbClr val="F3F7FA"/>
           </a:solidFill>
           <a:ln>
             <a:solidFill>
-              <a:srgbClr val="7FA48C"/>
+              <a:srgbClr val="7B9BB5"/>
             </a:solidFill>
           </a:ln>
           <a:effectLst/>
@@ -10378,7 +10378,7 @@
             <a:r>
               <a:rPr sz="750" b="0" i="0">
                 <a:solidFill>
-                  <a:srgbClr val="5B6B61"/>
+                  <a:srgbClr val="55677A"/>
                 </a:solidFill>
                 <a:latin typeface="Arial"/>
               </a:rPr>
@@ -10406,7 +10406,7 @@
           </a:solidFill>
           <a:ln>
             <a:solidFill>
-              <a:srgbClr val="6B7A70"/>
+              <a:srgbClr val="6B7A89"/>
             </a:solidFill>
             <a:prstDash val="dash"/>
           </a:ln>
@@ -10460,7 +10460,7 @@
             <a:r>
               <a:rPr sz="750" b="0" i="0">
                 <a:solidFill>
-                  <a:srgbClr val="5B6B61"/>
+                  <a:srgbClr val="55677A"/>
                 </a:solidFill>
                 <a:latin typeface="Arial"/>
               </a:rPr>
@@ -10506,7 +10506,7 @@
           </a:prstGeom>
           <a:ln w="15875">
             <a:solidFill>
-              <a:srgbClr val="4A5A50"/>
+              <a:srgbClr val="4A5867"/>
             </a:solidFill>
             <a:headEnd type="triangle" w="med" len="med"/>
           </a:ln>
@@ -10545,7 +10545,7 @@
           </a:prstGeom>
           <a:ln w="15875">
             <a:solidFill>
-              <a:srgbClr val="4A5A50"/>
+              <a:srgbClr val="4A5867"/>
             </a:solidFill>
             <a:headEnd type="triangle" w="med" len="med"/>
           </a:ln>
@@ -10584,7 +10584,7 @@
           </a:prstGeom>
           <a:ln w="15875">
             <a:solidFill>
-              <a:srgbClr val="4A5A50"/>
+              <a:srgbClr val="4A5867"/>
             </a:solidFill>
             <a:headEnd type="triangle" w="med" len="med"/>
           </a:ln>
@@ -10623,7 +10623,7 @@
           </a:prstGeom>
           <a:ln w="15875">
             <a:solidFill>
-              <a:srgbClr val="4A5A50"/>
+              <a:srgbClr val="4A5867"/>
             </a:solidFill>
             <a:headEnd type="triangle" w="med" len="med"/>
           </a:ln>
@@ -10662,7 +10662,7 @@
           </a:prstGeom>
           <a:ln w="15875">
             <a:solidFill>
-              <a:srgbClr val="4A5A50"/>
+              <a:srgbClr val="4A5867"/>
             </a:solidFill>
             <a:headEnd type="triangle" w="med" len="med"/>
           </a:ln>
@@ -10701,7 +10701,7 @@
           </a:prstGeom>
           <a:ln w="15875">
             <a:solidFill>
-              <a:srgbClr val="4A5A50"/>
+              <a:srgbClr val="4A5867"/>
             </a:solidFill>
             <a:headEnd type="triangle" w="med" len="med"/>
           </a:ln>
@@ -10740,7 +10740,7 @@
           </a:prstGeom>
           <a:ln w="15875">
             <a:solidFill>
-              <a:srgbClr val="4A5A50"/>
+              <a:srgbClr val="4A5867"/>
             </a:solidFill>
             <a:headEnd type="triangle" w="med" len="med"/>
           </a:ln>
@@ -10779,7 +10779,7 @@
           </a:prstGeom>
           <a:ln w="15875">
             <a:solidFill>
-              <a:srgbClr val="4A5A50"/>
+              <a:srgbClr val="4A5867"/>
             </a:solidFill>
             <a:headEnd type="triangle" w="med" len="med"/>
           </a:ln>
@@ -10818,7 +10818,7 @@
           </a:prstGeom>
           <a:ln w="15875">
             <a:solidFill>
-              <a:srgbClr val="4A5A50"/>
+              <a:srgbClr val="4A5867"/>
             </a:solidFill>
             <a:headEnd type="triangle" w="med" len="med"/>
           </a:ln>
@@ -10857,7 +10857,7 @@
           </a:prstGeom>
           <a:ln w="15875">
             <a:solidFill>
-              <a:srgbClr val="4A5A50"/>
+              <a:srgbClr val="4A5867"/>
             </a:solidFill>
             <a:headEnd type="triangle" w="med" len="med"/>
           </a:ln>
@@ -10896,7 +10896,7 @@
           </a:prstGeom>
           <a:ln w="15875">
             <a:solidFill>
-              <a:srgbClr val="4A5A50"/>
+              <a:srgbClr val="4A5867"/>
             </a:solidFill>
             <a:headEnd type="triangle" w="med" len="med"/>
           </a:ln>
@@ -10935,7 +10935,7 @@
           </a:prstGeom>
           <a:ln w="15875">
             <a:solidFill>
-              <a:srgbClr val="4A5A50"/>
+              <a:srgbClr val="4A5867"/>
             </a:solidFill>
             <a:headEnd type="triangle" w="med" len="med"/>
           </a:ln>
@@ -10974,7 +10974,7 @@
           </a:prstGeom>
           <a:ln w="15875">
             <a:solidFill>
-              <a:srgbClr val="4A5A50"/>
+              <a:srgbClr val="4A5867"/>
             </a:solidFill>
             <a:headEnd type="triangle" w="med" len="med"/>
           </a:ln>
@@ -11013,7 +11013,7 @@
           </a:prstGeom>
           <a:ln w="15875">
             <a:solidFill>
-              <a:srgbClr val="4A5A50"/>
+              <a:srgbClr val="4A5867"/>
             </a:solidFill>
           </a:ln>
         </p:spPr>
@@ -11051,7 +11051,7 @@
           </a:prstGeom>
           <a:ln w="15875">
             <a:solidFill>
-              <a:srgbClr val="4A5A50"/>
+              <a:srgbClr val="4A5867"/>
             </a:solidFill>
           </a:ln>
         </p:spPr>
@@ -11089,7 +11089,7 @@
           </a:prstGeom>
           <a:ln w="15875">
             <a:solidFill>
-              <a:srgbClr val="4A5A50"/>
+              <a:srgbClr val="4A5867"/>
             </a:solidFill>
           </a:ln>
         </p:spPr>
@@ -11127,7 +11127,7 @@
           </a:prstGeom>
           <a:ln w="15875">
             <a:solidFill>
-              <a:srgbClr val="4A5A50"/>
+              <a:srgbClr val="4A5867"/>
             </a:solidFill>
           </a:ln>
         </p:spPr>
@@ -11165,7 +11165,7 @@
           </a:prstGeom>
           <a:ln w="15875">
             <a:solidFill>
-              <a:srgbClr val="4A5A50"/>
+              <a:srgbClr val="4A5867"/>
             </a:solidFill>
           </a:ln>
         </p:spPr>
@@ -11203,7 +11203,7 @@
           </a:prstGeom>
           <a:ln w="15875">
             <a:solidFill>
-              <a:srgbClr val="4A5A50"/>
+              <a:srgbClr val="4A5867"/>
             </a:solidFill>
           </a:ln>
         </p:spPr>
@@ -11241,7 +11241,7 @@
           </a:prstGeom>
           <a:ln w="15875">
             <a:solidFill>
-              <a:srgbClr val="4A5A50"/>
+              <a:srgbClr val="4A5867"/>
             </a:solidFill>
           </a:ln>
         </p:spPr>
@@ -11279,7 +11279,7 @@
           </a:prstGeom>
           <a:ln w="15875">
             <a:solidFill>
-              <a:srgbClr val="4A5A50"/>
+              <a:srgbClr val="4A5867"/>
             </a:solidFill>
           </a:ln>
         </p:spPr>
@@ -11317,7 +11317,7 @@
           </a:prstGeom>
           <a:ln w="15875">
             <a:solidFill>
-              <a:srgbClr val="4A5A50"/>
+              <a:srgbClr val="4A5867"/>
             </a:solidFill>
           </a:ln>
         </p:spPr>
@@ -11355,7 +11355,7 @@
           </a:prstGeom>
           <a:ln w="15875">
             <a:solidFill>
-              <a:srgbClr val="4A5A50"/>
+              <a:srgbClr val="4A5867"/>
             </a:solidFill>
           </a:ln>
         </p:spPr>
@@ -11393,7 +11393,7 @@
           </a:prstGeom>
           <a:ln w="15875">
             <a:solidFill>
-              <a:srgbClr val="4A5A50"/>
+              <a:srgbClr val="4A5867"/>
             </a:solidFill>
             <a:headEnd type="triangle" w="med" len="med"/>
           </a:ln>
@@ -11432,7 +11432,7 @@
           </a:prstGeom>
           <a:ln w="15875">
             <a:solidFill>
-              <a:srgbClr val="4A5A50"/>
+              <a:srgbClr val="4A5867"/>
             </a:solidFill>
             <a:headEnd type="triangle" w="med" len="med"/>
           </a:ln>
@@ -11471,7 +11471,7 @@
           </a:prstGeom>
           <a:ln w="15875">
             <a:solidFill>
-              <a:srgbClr val="4A5A50"/>
+              <a:srgbClr val="4A5867"/>
             </a:solidFill>
             <a:headEnd type="triangle" w="med" len="med"/>
           </a:ln>
@@ -11510,7 +11510,7 @@
           </a:prstGeom>
           <a:ln w="15875">
             <a:solidFill>
-              <a:srgbClr val="6B7A70"/>
+              <a:srgbClr val="6B7A89"/>
             </a:solidFill>
             <a:prstDash val="dash"/>
             <a:tailEnd type="triangle"/>
@@ -11550,7 +11550,7 @@
           </a:prstGeom>
           <a:ln w="15875">
             <a:solidFill>
-              <a:srgbClr val="6B7A70"/>
+              <a:srgbClr val="6B7A89"/>
             </a:solidFill>
             <a:prstDash val="dash"/>
             <a:tailEnd type="triangle"/>
@@ -11586,7 +11586,7 @@
             <a:avLst/>
           </a:prstGeom>
           <a:solidFill>
-            <a:srgbClr val="1B4D2E"/>
+            <a:srgbClr val="1B4F72"/>
           </a:solidFill>
           <a:ln>
             <a:noFill/>
@@ -11674,7 +11674,7 @@
             <a:r>
               <a:rPr sz="750" b="0" i="0">
                 <a:solidFill>
-                  <a:srgbClr val="5B6B61"/>
+                  <a:srgbClr val="55677A"/>
                 </a:solidFill>
                 <a:latin typeface="Arial"/>
               </a:rPr>
@@ -11786,7 +11786,7 @@
             <a:r>
               <a:rPr sz="994" b="1" i="0">
                 <a:solidFill>
-                  <a:srgbClr val="1E2A22"/>
+                  <a:srgbClr val="1B2733"/>
                 </a:solidFill>
                 <a:latin typeface="Arial"/>
               </a:rPr>
@@ -11795,7 +11795,7 @@
             <a:r>
               <a:rPr sz="1275" b="0" i="0">
                 <a:solidFill>
-                  <a:srgbClr val="1E2A22"/>
+                  <a:srgbClr val="1B2733"/>
                 </a:solidFill>
                 <a:latin typeface="Arial"/>
               </a:rPr>
@@ -11850,7 +11850,7 @@
             <a:r>
               <a:rPr sz="994" b="1" i="0">
                 <a:solidFill>
-                  <a:srgbClr val="1E2A22"/>
+                  <a:srgbClr val="1B2733"/>
                 </a:solidFill>
                 <a:latin typeface="Arial"/>
               </a:rPr>
@@ -11859,7 +11859,7 @@
             <a:r>
               <a:rPr sz="1275" b="0" i="0">
                 <a:solidFill>
-                  <a:srgbClr val="1E2A22"/>
+                  <a:srgbClr val="1B2733"/>
                 </a:solidFill>
                 <a:latin typeface="Arial"/>
               </a:rPr>
@@ -11914,7 +11914,7 @@
             <a:r>
               <a:rPr sz="994" b="1" i="0">
                 <a:solidFill>
-                  <a:srgbClr val="1E2A22"/>
+                  <a:srgbClr val="1B2733"/>
                 </a:solidFill>
                 <a:latin typeface="Arial"/>
               </a:rPr>
@@ -11923,7 +11923,7 @@
             <a:r>
               <a:rPr sz="1275" b="0" i="0">
                 <a:solidFill>
-                  <a:srgbClr val="1E2A22"/>
+                  <a:srgbClr val="1B2733"/>
                 </a:solidFill>
                 <a:latin typeface="Arial"/>
               </a:rPr>
@@ -11978,7 +11978,7 @@
             <a:r>
               <a:rPr sz="994" b="1" i="0">
                 <a:solidFill>
-                  <a:srgbClr val="1E2A22"/>
+                  <a:srgbClr val="1B2733"/>
                 </a:solidFill>
                 <a:latin typeface="Arial"/>
               </a:rPr>
@@ -11987,7 +11987,7 @@
             <a:r>
               <a:rPr sz="1275" b="0" i="0">
                 <a:solidFill>
-                  <a:srgbClr val="1E2A22"/>
+                  <a:srgbClr val="1B2733"/>
                 </a:solidFill>
                 <a:latin typeface="Arial"/>
               </a:rPr>
@@ -12042,7 +12042,7 @@
             <a:r>
               <a:rPr sz="1053" b="1" i="0">
                 <a:solidFill>
-                  <a:srgbClr val="1E2A22"/>
+                  <a:srgbClr val="1B2733"/>
                 </a:solidFill>
                 <a:latin typeface="Arial"/>
               </a:rPr>
@@ -12051,7 +12051,7 @@
             <a:r>
               <a:rPr sz="1350" b="1" i="0">
                 <a:solidFill>
-                  <a:srgbClr val="1E2A22"/>
+                  <a:srgbClr val="1B2733"/>
                 </a:solidFill>
                 <a:latin typeface="Arial"/>
               </a:rPr>
@@ -12106,7 +12106,7 @@
             <a:r>
               <a:rPr sz="1053" b="1" i="0">
                 <a:solidFill>
-                  <a:srgbClr val="1E2A22"/>
+                  <a:srgbClr val="1B2733"/>
                 </a:solidFill>
                 <a:latin typeface="Arial"/>
               </a:rPr>
@@ -12115,7 +12115,7 @@
             <a:r>
               <a:rPr sz="1350" b="1" i="0">
                 <a:solidFill>
-                  <a:srgbClr val="1E2A22"/>
+                  <a:srgbClr val="1B2733"/>
                 </a:solidFill>
                 <a:latin typeface="Arial"/>
               </a:rPr>
@@ -12170,7 +12170,7 @@
             <a:r>
               <a:rPr sz="1053" b="1" i="0">
                 <a:solidFill>
-                  <a:srgbClr val="1E2A22"/>
+                  <a:srgbClr val="1B2733"/>
                 </a:solidFill>
                 <a:latin typeface="Arial"/>
               </a:rPr>
@@ -12179,7 +12179,7 @@
             <a:r>
               <a:rPr sz="1350" b="1" i="0">
                 <a:solidFill>
-                  <a:srgbClr val="1E2A22"/>
+                  <a:srgbClr val="1B2733"/>
                 </a:solidFill>
                 <a:latin typeface="Arial"/>
               </a:rPr>
@@ -12205,11 +12205,11 @@
             </a:avLst>
           </a:prstGeom>
           <a:solidFill>
-            <a:srgbClr val="1B4D2E"/>
+            <a:srgbClr val="1B4F72"/>
           </a:solidFill>
           <a:ln w="12700">
             <a:solidFill>
-              <a:srgbClr val="1B4D2E"/>
+              <a:srgbClr val="1B4F72"/>
             </a:solidFill>
           </a:ln>
           <a:effectLst/>
@@ -12264,7 +12264,7 @@
           </a:solidFill>
           <a:ln w="12700">
             <a:solidFill>
-              <a:srgbClr val="6B7A70"/>
+              <a:srgbClr val="6B7A89"/>
             </a:solidFill>
             <a:prstDash val="dash"/>
           </a:ln>
@@ -12292,7 +12292,7 @@
             <a:r>
               <a:rPr sz="1150" b="1" i="0">
                 <a:solidFill>
-                  <a:srgbClr val="5B6B61"/>
+                  <a:srgbClr val="55677A"/>
                 </a:solidFill>
                 <a:latin typeface="Arial"/>
               </a:rPr>
@@ -12304,7 +12304,7 @@
             <a:r>
               <a:rPr sz="1150" b="0" i="0">
                 <a:solidFill>
-                  <a:srgbClr val="5B6B61"/>
+                  <a:srgbClr val="55677A"/>
                 </a:solidFill>
                 <a:latin typeface="Arial"/>
               </a:rPr>
@@ -12332,7 +12332,7 @@
           </a:solidFill>
           <a:ln w="12700">
             <a:solidFill>
-              <a:srgbClr val="6B7A70"/>
+              <a:srgbClr val="6B7A89"/>
             </a:solidFill>
             <a:prstDash val="dash"/>
           </a:ln>
@@ -12360,7 +12360,7 @@
             <a:r>
               <a:rPr sz="1150" b="1" i="0">
                 <a:solidFill>
-                  <a:srgbClr val="5B6B61"/>
+                  <a:srgbClr val="55677A"/>
                 </a:solidFill>
                 <a:latin typeface="Arial"/>
               </a:rPr>
@@ -12372,7 +12372,7 @@
             <a:r>
               <a:rPr sz="1150" b="0" i="0">
                 <a:solidFill>
-                  <a:srgbClr val="5B6B61"/>
+                  <a:srgbClr val="55677A"/>
                 </a:solidFill>
                 <a:latin typeface="Arial"/>
               </a:rPr>
@@ -12396,11 +12396,11 @@
             <a:avLst/>
           </a:prstGeom>
           <a:solidFill>
-            <a:srgbClr val="E8F0EA"/>
+            <a:srgbClr val="E5EEF6"/>
           </a:solidFill>
           <a:ln w="22225">
             <a:solidFill>
-              <a:srgbClr val="1B4D2E"/>
+              <a:srgbClr val="1B4F72"/>
             </a:solidFill>
           </a:ln>
           <a:effectLst/>
@@ -12427,7 +12427,7 @@
             <a:r>
               <a:rPr sz="1053" b="1" i="0">
                 <a:solidFill>
-                  <a:srgbClr val="1E2A22"/>
+                  <a:srgbClr val="1B2733"/>
                 </a:solidFill>
                 <a:latin typeface="Arial"/>
               </a:rPr>
@@ -12436,7 +12436,7 @@
             <a:r>
               <a:rPr sz="1350" b="1" i="0">
                 <a:solidFill>
-                  <a:srgbClr val="1E2A22"/>
+                  <a:srgbClr val="1B2733"/>
                 </a:solidFill>
                 <a:latin typeface="Arial"/>
               </a:rPr>
@@ -12460,11 +12460,11 @@
             <a:avLst/>
           </a:prstGeom>
           <a:solidFill>
-            <a:srgbClr val="E8F0EA"/>
+            <a:srgbClr val="E5EEF6"/>
           </a:solidFill>
           <a:ln w="22225">
             <a:solidFill>
-              <a:srgbClr val="1B4D2E"/>
+              <a:srgbClr val="1B4F72"/>
             </a:solidFill>
           </a:ln>
           <a:effectLst/>
@@ -12491,7 +12491,7 @@
             <a:r>
               <a:rPr sz="1053" b="1" i="0">
                 <a:solidFill>
-                  <a:srgbClr val="1E2A22"/>
+                  <a:srgbClr val="1B2733"/>
                 </a:solidFill>
                 <a:latin typeface="Arial"/>
               </a:rPr>
@@ -12500,7 +12500,7 @@
             <a:r>
               <a:rPr sz="1350" b="1" i="0">
                 <a:solidFill>
-                  <a:srgbClr val="1E2A22"/>
+                  <a:srgbClr val="1B2733"/>
                 </a:solidFill>
                 <a:latin typeface="Arial"/>
               </a:rPr>
@@ -12524,11 +12524,11 @@
             <a:avLst/>
           </a:prstGeom>
           <a:solidFill>
-            <a:srgbClr val="E8F0EA"/>
+            <a:srgbClr val="E5EEF6"/>
           </a:solidFill>
           <a:ln w="22225">
             <a:solidFill>
-              <a:srgbClr val="1B4D2E"/>
+              <a:srgbClr val="1B4F72"/>
             </a:solidFill>
           </a:ln>
           <a:effectLst/>
@@ -12555,7 +12555,7 @@
             <a:r>
               <a:rPr sz="1053" b="1" i="0">
                 <a:solidFill>
-                  <a:srgbClr val="1E2A22"/>
+                  <a:srgbClr val="1B2733"/>
                 </a:solidFill>
                 <a:latin typeface="Arial"/>
               </a:rPr>
@@ -12564,7 +12564,7 @@
             <a:r>
               <a:rPr sz="1350" b="1" i="0">
                 <a:solidFill>
-                  <a:srgbClr val="1E2A22"/>
+                  <a:srgbClr val="1B2733"/>
                 </a:solidFill>
                 <a:latin typeface="Arial"/>
               </a:rPr>
@@ -12588,11 +12588,11 @@
             <a:avLst/>
           </a:prstGeom>
           <a:solidFill>
-            <a:srgbClr val="F4F8F5"/>
+            <a:srgbClr val="F3F7FA"/>
           </a:solidFill>
           <a:ln w="12700">
             <a:solidFill>
-              <a:srgbClr val="7FA48C"/>
+              <a:srgbClr val="7B9BB5"/>
             </a:solidFill>
           </a:ln>
           <a:effectLst/>
@@ -12619,7 +12619,7 @@
             <a:r>
               <a:rPr sz="955" b="1" i="0">
                 <a:solidFill>
-                  <a:srgbClr val="1E2A22"/>
+                  <a:srgbClr val="1B2733"/>
                 </a:solidFill>
                 <a:latin typeface="Arial"/>
               </a:rPr>
@@ -12628,7 +12628,7 @@
             <a:r>
               <a:rPr sz="1225" b="0" i="0">
                 <a:solidFill>
-                  <a:srgbClr val="1E2A22"/>
+                  <a:srgbClr val="1B2733"/>
                 </a:solidFill>
                 <a:latin typeface="Arial"/>
               </a:rPr>
@@ -12652,11 +12652,11 @@
             <a:avLst/>
           </a:prstGeom>
           <a:solidFill>
-            <a:srgbClr val="F4F8F5"/>
+            <a:srgbClr val="F3F7FA"/>
           </a:solidFill>
           <a:ln w="12700">
             <a:solidFill>
-              <a:srgbClr val="7FA48C"/>
+              <a:srgbClr val="7B9BB5"/>
             </a:solidFill>
           </a:ln>
           <a:effectLst/>
@@ -12683,7 +12683,7 @@
             <a:r>
               <a:rPr sz="955" b="1" i="0">
                 <a:solidFill>
-                  <a:srgbClr val="1E2A22"/>
+                  <a:srgbClr val="1B2733"/>
                 </a:solidFill>
                 <a:latin typeface="Arial"/>
               </a:rPr>
@@ -12692,7 +12692,7 @@
             <a:r>
               <a:rPr sz="1225" b="0" i="0">
                 <a:solidFill>
-                  <a:srgbClr val="1E2A22"/>
+                  <a:srgbClr val="1B2733"/>
                 </a:solidFill>
                 <a:latin typeface="Arial"/>
               </a:rPr>
@@ -12716,11 +12716,11 @@
             <a:avLst/>
           </a:prstGeom>
           <a:solidFill>
-            <a:srgbClr val="F4F8F5"/>
+            <a:srgbClr val="F3F7FA"/>
           </a:solidFill>
           <a:ln w="12700">
             <a:solidFill>
-              <a:srgbClr val="7FA48C"/>
+              <a:srgbClr val="7B9BB5"/>
             </a:solidFill>
           </a:ln>
           <a:effectLst/>
@@ -12747,7 +12747,7 @@
             <a:r>
               <a:rPr sz="955" b="1" i="0">
                 <a:solidFill>
-                  <a:srgbClr val="1E2A22"/>
+                  <a:srgbClr val="1B2733"/>
                 </a:solidFill>
                 <a:latin typeface="Arial"/>
               </a:rPr>
@@ -12756,7 +12756,7 @@
             <a:r>
               <a:rPr sz="1225" b="0" i="0">
                 <a:solidFill>
-                  <a:srgbClr val="1E2A22"/>
+                  <a:srgbClr val="1B2733"/>
                 </a:solidFill>
                 <a:latin typeface="Arial"/>
               </a:rPr>
@@ -12780,11 +12780,11 @@
             <a:avLst/>
           </a:prstGeom>
           <a:solidFill>
-            <a:srgbClr val="F4F8F5"/>
+            <a:srgbClr val="F3F7FA"/>
           </a:solidFill>
           <a:ln w="12700">
             <a:solidFill>
-              <a:srgbClr val="7FA48C"/>
+              <a:srgbClr val="7B9BB5"/>
             </a:solidFill>
           </a:ln>
           <a:effectLst/>
@@ -12811,7 +12811,7 @@
             <a:r>
               <a:rPr sz="955" b="1" i="0">
                 <a:solidFill>
-                  <a:srgbClr val="1E2A22"/>
+                  <a:srgbClr val="1B2733"/>
                 </a:solidFill>
                 <a:latin typeface="Arial"/>
               </a:rPr>
@@ -12820,7 +12820,7 @@
             <a:r>
               <a:rPr sz="1225" b="0" i="0">
                 <a:solidFill>
-                  <a:srgbClr val="1E2A22"/>
+                  <a:srgbClr val="1B2733"/>
                 </a:solidFill>
                 <a:latin typeface="Arial"/>
               </a:rPr>
@@ -12844,11 +12844,11 @@
             <a:avLst/>
           </a:prstGeom>
           <a:solidFill>
-            <a:srgbClr val="F4F8F5"/>
+            <a:srgbClr val="F3F7FA"/>
           </a:solidFill>
           <a:ln w="12700">
             <a:solidFill>
-              <a:srgbClr val="7FA48C"/>
+              <a:srgbClr val="7B9BB5"/>
             </a:solidFill>
           </a:ln>
           <a:effectLst/>
@@ -12875,7 +12875,7 @@
             <a:r>
               <a:rPr sz="955" b="1" i="0">
                 <a:solidFill>
-                  <a:srgbClr val="1E2A22"/>
+                  <a:srgbClr val="1B2733"/>
                 </a:solidFill>
                 <a:latin typeface="Arial"/>
               </a:rPr>
@@ -12884,7 +12884,7 @@
             <a:r>
               <a:rPr sz="1225" b="0" i="0">
                 <a:solidFill>
-                  <a:srgbClr val="1E2A22"/>
+                  <a:srgbClr val="1B2733"/>
                 </a:solidFill>
                 <a:latin typeface="Arial"/>
               </a:rPr>
@@ -12908,11 +12908,11 @@
             <a:avLst/>
           </a:prstGeom>
           <a:solidFill>
-            <a:srgbClr val="F4F8F5"/>
+            <a:srgbClr val="F3F7FA"/>
           </a:solidFill>
           <a:ln w="12700">
             <a:solidFill>
-              <a:srgbClr val="7FA48C"/>
+              <a:srgbClr val="7B9BB5"/>
             </a:solidFill>
           </a:ln>
           <a:effectLst/>
@@ -12939,7 +12939,7 @@
             <a:r>
               <a:rPr sz="955" b="1" i="0">
                 <a:solidFill>
-                  <a:srgbClr val="1E2A22"/>
+                  <a:srgbClr val="1B2733"/>
                 </a:solidFill>
                 <a:latin typeface="Arial"/>
               </a:rPr>
@@ -12948,7 +12948,7 @@
             <a:r>
               <a:rPr sz="1225" b="0" i="0">
                 <a:solidFill>
-                  <a:srgbClr val="1E2A22"/>
+                  <a:srgbClr val="1B2733"/>
                 </a:solidFill>
                 <a:latin typeface="Arial"/>
               </a:rPr>
@@ -12972,11 +12972,11 @@
             <a:avLst/>
           </a:prstGeom>
           <a:solidFill>
-            <a:srgbClr val="F4F8F5"/>
+            <a:srgbClr val="F3F7FA"/>
           </a:solidFill>
           <a:ln w="12700">
             <a:solidFill>
-              <a:srgbClr val="7FA48C"/>
+              <a:srgbClr val="7B9BB5"/>
             </a:solidFill>
           </a:ln>
           <a:effectLst/>
@@ -13003,7 +13003,7 @@
             <a:r>
               <a:rPr sz="955" b="1" i="0">
                 <a:solidFill>
-                  <a:srgbClr val="1E2A22"/>
+                  <a:srgbClr val="1B2733"/>
                 </a:solidFill>
                 <a:latin typeface="Arial"/>
               </a:rPr>
@@ -13012,7 +13012,7 @@
             <a:r>
               <a:rPr sz="1225" b="0" i="0">
                 <a:solidFill>
-                  <a:srgbClr val="1E2A22"/>
+                  <a:srgbClr val="1B2733"/>
                 </a:solidFill>
                 <a:latin typeface="Arial"/>
               </a:rPr>
@@ -13036,11 +13036,11 @@
             <a:avLst/>
           </a:prstGeom>
           <a:solidFill>
-            <a:srgbClr val="F4F8F5"/>
+            <a:srgbClr val="F3F7FA"/>
           </a:solidFill>
           <a:ln w="12700">
             <a:solidFill>
-              <a:srgbClr val="7FA48C"/>
+              <a:srgbClr val="7B9BB5"/>
             </a:solidFill>
           </a:ln>
           <a:effectLst/>
@@ -13067,7 +13067,7 @@
             <a:r>
               <a:rPr sz="955" b="1" i="0">
                 <a:solidFill>
-                  <a:srgbClr val="1E2A22"/>
+                  <a:srgbClr val="1B2733"/>
                 </a:solidFill>
                 <a:latin typeface="Arial"/>
               </a:rPr>
@@ -13076,7 +13076,7 @@
             <a:r>
               <a:rPr sz="1225" b="0" i="0">
                 <a:solidFill>
-                  <a:srgbClr val="1E2A22"/>
+                  <a:srgbClr val="1B2733"/>
                 </a:solidFill>
                 <a:latin typeface="Arial"/>
               </a:rPr>
@@ -13100,11 +13100,11 @@
             <a:avLst/>
           </a:prstGeom>
           <a:solidFill>
-            <a:srgbClr val="F4F8F5"/>
+            <a:srgbClr val="F3F7FA"/>
           </a:solidFill>
           <a:ln w="12700">
             <a:solidFill>
-              <a:srgbClr val="7FA48C"/>
+              <a:srgbClr val="7B9BB5"/>
             </a:solidFill>
           </a:ln>
           <a:effectLst/>
@@ -13131,7 +13131,7 @@
             <a:r>
               <a:rPr sz="955" b="1" i="0">
                 <a:solidFill>
-                  <a:srgbClr val="1E2A22"/>
+                  <a:srgbClr val="1B2733"/>
                 </a:solidFill>
                 <a:latin typeface="Arial"/>
               </a:rPr>
@@ -13140,7 +13140,7 @@
             <a:r>
               <a:rPr sz="1225" b="0" i="0">
                 <a:solidFill>
-                  <a:srgbClr val="1E2A22"/>
+                  <a:srgbClr val="1B2733"/>
                 </a:solidFill>
                 <a:latin typeface="Arial"/>
               </a:rPr>
@@ -13164,11 +13164,11 @@
             <a:avLst/>
           </a:prstGeom>
           <a:solidFill>
-            <a:srgbClr val="F4F8F5"/>
+            <a:srgbClr val="F3F7FA"/>
           </a:solidFill>
           <a:ln w="12700">
             <a:solidFill>
-              <a:srgbClr val="7FA48C"/>
+              <a:srgbClr val="7B9BB5"/>
             </a:solidFill>
           </a:ln>
           <a:effectLst/>
@@ -13195,7 +13195,7 @@
             <a:r>
               <a:rPr sz="955" b="1" i="0">
                 <a:solidFill>
-                  <a:srgbClr val="1E2A22"/>
+                  <a:srgbClr val="1B2733"/>
                 </a:solidFill>
                 <a:latin typeface="Arial"/>
               </a:rPr>
@@ -13204,7 +13204,7 @@
             <a:r>
               <a:rPr sz="1225" b="0" i="0">
                 <a:solidFill>
-                  <a:srgbClr val="1E2A22"/>
+                  <a:srgbClr val="1B2733"/>
                 </a:solidFill>
                 <a:latin typeface="Arial"/>
               </a:rPr>
@@ -13285,7 +13285,7 @@
             <a:r>
               <a:rPr sz="750" b="0" i="0">
                 <a:solidFill>
-                  <a:srgbClr val="5B6B61"/>
+                  <a:srgbClr val="55677A"/>
                 </a:solidFill>
                 <a:latin typeface="Arial"/>
               </a:rPr>
@@ -13366,7 +13366,7 @@
             <a:r>
               <a:rPr sz="750" b="0" i="0">
                 <a:solidFill>
-                  <a:srgbClr val="5B6B61"/>
+                  <a:srgbClr val="55677A"/>
                 </a:solidFill>
                 <a:latin typeface="Arial"/>
               </a:rPr>
@@ -13447,7 +13447,7 @@
             <a:r>
               <a:rPr sz="750" b="0" i="0">
                 <a:solidFill>
-                  <a:srgbClr val="5B6B61"/>
+                  <a:srgbClr val="55677A"/>
                 </a:solidFill>
                 <a:latin typeface="Arial"/>
               </a:rPr>
@@ -13471,11 +13471,11 @@
             <a:avLst/>
           </a:prstGeom>
           <a:solidFill>
-            <a:srgbClr val="1B4D2E"/>
+            <a:srgbClr val="1B4F72"/>
           </a:solidFill>
           <a:ln>
             <a:solidFill>
-              <a:srgbClr val="1B4D2E"/>
+              <a:srgbClr val="1B4F72"/>
             </a:solidFill>
           </a:ln>
           <a:effectLst/>
@@ -13528,7 +13528,7 @@
             <a:r>
               <a:rPr sz="750" b="0" i="0">
                 <a:solidFill>
-                  <a:srgbClr val="5B6B61"/>
+                  <a:srgbClr val="55677A"/>
                 </a:solidFill>
                 <a:latin typeface="Arial"/>
               </a:rPr>
@@ -13552,11 +13552,11 @@
             <a:avLst/>
           </a:prstGeom>
           <a:solidFill>
-            <a:srgbClr val="E8F0EA"/>
+            <a:srgbClr val="E5EEF6"/>
           </a:solidFill>
           <a:ln>
             <a:solidFill>
-              <a:srgbClr val="1B4D2E"/>
+              <a:srgbClr val="1B4F72"/>
             </a:solidFill>
           </a:ln>
           <a:effectLst/>
@@ -13609,7 +13609,7 @@
             <a:r>
               <a:rPr sz="750" b="0" i="0">
                 <a:solidFill>
-                  <a:srgbClr val="5B6B61"/>
+                  <a:srgbClr val="55677A"/>
                 </a:solidFill>
                 <a:latin typeface="Arial"/>
               </a:rPr>
@@ -13633,11 +13633,11 @@
             <a:avLst/>
           </a:prstGeom>
           <a:solidFill>
-            <a:srgbClr val="F4F8F5"/>
+            <a:srgbClr val="F3F7FA"/>
           </a:solidFill>
           <a:ln>
             <a:solidFill>
-              <a:srgbClr val="7FA48C"/>
+              <a:srgbClr val="7B9BB5"/>
             </a:solidFill>
           </a:ln>
           <a:effectLst/>
@@ -13690,7 +13690,7 @@
             <a:r>
               <a:rPr sz="750" b="0" i="0">
                 <a:solidFill>
-                  <a:srgbClr val="5B6B61"/>
+                  <a:srgbClr val="55677A"/>
                 </a:solidFill>
                 <a:latin typeface="Arial"/>
               </a:rPr>
@@ -13718,7 +13718,7 @@
           </a:solidFill>
           <a:ln>
             <a:solidFill>
-              <a:srgbClr val="6B7A70"/>
+              <a:srgbClr val="6B7A89"/>
             </a:solidFill>
             <a:prstDash val="dash"/>
           </a:ln>
@@ -13772,7 +13772,7 @@
             <a:r>
               <a:rPr sz="750" b="0" i="0">
                 <a:solidFill>
-                  <a:srgbClr val="5B6B61"/>
+                  <a:srgbClr val="55677A"/>
                 </a:solidFill>
                 <a:latin typeface="Arial"/>
               </a:rPr>
@@ -13818,7 +13818,7 @@
           </a:prstGeom>
           <a:ln w="15875">
             <a:solidFill>
-              <a:srgbClr val="4A5A50"/>
+              <a:srgbClr val="4A5867"/>
             </a:solidFill>
             <a:headEnd type="triangle" w="med" len="med"/>
           </a:ln>
@@ -13857,7 +13857,7 @@
           </a:prstGeom>
           <a:ln w="15875">
             <a:solidFill>
-              <a:srgbClr val="4A5A50"/>
+              <a:srgbClr val="4A5867"/>
             </a:solidFill>
             <a:headEnd type="triangle" w="med" len="med"/>
           </a:ln>
@@ -13896,7 +13896,7 @@
           </a:prstGeom>
           <a:ln w="15875">
             <a:solidFill>
-              <a:srgbClr val="4A5A50"/>
+              <a:srgbClr val="4A5867"/>
             </a:solidFill>
             <a:headEnd type="triangle" w="med" len="med"/>
           </a:ln>
@@ -13935,7 +13935,7 @@
           </a:prstGeom>
           <a:ln w="15875">
             <a:solidFill>
-              <a:srgbClr val="4A5A50"/>
+              <a:srgbClr val="4A5867"/>
             </a:solidFill>
             <a:headEnd type="triangle" w="med" len="med"/>
           </a:ln>
@@ -13974,7 +13974,7 @@
           </a:prstGeom>
           <a:ln w="15875">
             <a:solidFill>
-              <a:srgbClr val="4A5A50"/>
+              <a:srgbClr val="4A5867"/>
             </a:solidFill>
             <a:headEnd type="triangle" w="med" len="med"/>
           </a:ln>
@@ -14013,7 +14013,7 @@
           </a:prstGeom>
           <a:ln w="15875">
             <a:solidFill>
-              <a:srgbClr val="4A5A50"/>
+              <a:srgbClr val="4A5867"/>
             </a:solidFill>
             <a:headEnd type="triangle" w="med" len="med"/>
           </a:ln>
@@ -14052,7 +14052,7 @@
           </a:prstGeom>
           <a:ln w="15875">
             <a:solidFill>
-              <a:srgbClr val="4A5A50"/>
+              <a:srgbClr val="4A5867"/>
             </a:solidFill>
             <a:headEnd type="triangle" w="med" len="med"/>
           </a:ln>
@@ -14091,7 +14091,7 @@
           </a:prstGeom>
           <a:ln w="15875">
             <a:solidFill>
-              <a:srgbClr val="4A5A50"/>
+              <a:srgbClr val="4A5867"/>
             </a:solidFill>
             <a:headEnd type="triangle" w="med" len="med"/>
           </a:ln>
@@ -14130,7 +14130,7 @@
           </a:prstGeom>
           <a:ln w="15875">
             <a:solidFill>
-              <a:srgbClr val="4A5A50"/>
+              <a:srgbClr val="4A5867"/>
             </a:solidFill>
             <a:headEnd type="triangle" w="med" len="med"/>
           </a:ln>
@@ -14169,7 +14169,7 @@
           </a:prstGeom>
           <a:ln w="15875">
             <a:solidFill>
-              <a:srgbClr val="4A5A50"/>
+              <a:srgbClr val="4A5867"/>
             </a:solidFill>
             <a:headEnd type="triangle" w="med" len="med"/>
           </a:ln>
@@ -14208,7 +14208,7 @@
           </a:prstGeom>
           <a:ln w="15875">
             <a:solidFill>
-              <a:srgbClr val="4A5A50"/>
+              <a:srgbClr val="4A5867"/>
             </a:solidFill>
             <a:headEnd type="triangle" w="med" len="med"/>
           </a:ln>
@@ -14247,7 +14247,7 @@
           </a:prstGeom>
           <a:ln w="15875">
             <a:solidFill>
-              <a:srgbClr val="4A5A50"/>
+              <a:srgbClr val="4A5867"/>
             </a:solidFill>
             <a:headEnd type="triangle" w="med" len="med"/>
           </a:ln>
@@ -14286,7 +14286,7 @@
           </a:prstGeom>
           <a:ln w="15875">
             <a:solidFill>
-              <a:srgbClr val="4A5A50"/>
+              <a:srgbClr val="4A5867"/>
             </a:solidFill>
           </a:ln>
         </p:spPr>
@@ -14324,7 +14324,7 @@
           </a:prstGeom>
           <a:ln w="15875">
             <a:solidFill>
-              <a:srgbClr val="4A5A50"/>
+              <a:srgbClr val="4A5867"/>
             </a:solidFill>
           </a:ln>
         </p:spPr>
@@ -14362,7 +14362,7 @@
           </a:prstGeom>
           <a:ln w="15875">
             <a:solidFill>
-              <a:srgbClr val="4A5A50"/>
+              <a:srgbClr val="4A5867"/>
             </a:solidFill>
           </a:ln>
         </p:spPr>
@@ -14400,7 +14400,7 @@
           </a:prstGeom>
           <a:ln w="15875">
             <a:solidFill>
-              <a:srgbClr val="4A5A50"/>
+              <a:srgbClr val="4A5867"/>
             </a:solidFill>
           </a:ln>
         </p:spPr>
@@ -14438,7 +14438,7 @@
           </a:prstGeom>
           <a:ln w="15875">
             <a:solidFill>
-              <a:srgbClr val="4A5A50"/>
+              <a:srgbClr val="4A5867"/>
             </a:solidFill>
           </a:ln>
         </p:spPr>
@@ -14476,7 +14476,7 @@
           </a:prstGeom>
           <a:ln w="15875">
             <a:solidFill>
-              <a:srgbClr val="4A5A50"/>
+              <a:srgbClr val="4A5867"/>
             </a:solidFill>
           </a:ln>
         </p:spPr>
@@ -14514,7 +14514,7 @@
           </a:prstGeom>
           <a:ln w="15875">
             <a:solidFill>
-              <a:srgbClr val="4A5A50"/>
+              <a:srgbClr val="4A5867"/>
             </a:solidFill>
           </a:ln>
         </p:spPr>
@@ -14552,7 +14552,7 @@
           </a:prstGeom>
           <a:ln w="15875">
             <a:solidFill>
-              <a:srgbClr val="4A5A50"/>
+              <a:srgbClr val="4A5867"/>
             </a:solidFill>
           </a:ln>
         </p:spPr>
@@ -14590,7 +14590,7 @@
           </a:prstGeom>
           <a:ln w="15875">
             <a:solidFill>
-              <a:srgbClr val="4A5A50"/>
+              <a:srgbClr val="4A5867"/>
             </a:solidFill>
           </a:ln>
         </p:spPr>
@@ -14628,7 +14628,7 @@
           </a:prstGeom>
           <a:ln w="15875">
             <a:solidFill>
-              <a:srgbClr val="4A5A50"/>
+              <a:srgbClr val="4A5867"/>
             </a:solidFill>
           </a:ln>
         </p:spPr>
@@ -14666,7 +14666,7 @@
           </a:prstGeom>
           <a:ln w="15875">
             <a:solidFill>
-              <a:srgbClr val="4A5A50"/>
+              <a:srgbClr val="4A5867"/>
             </a:solidFill>
             <a:headEnd type="triangle" w="med" len="med"/>
           </a:ln>
@@ -14705,7 +14705,7 @@
           </a:prstGeom>
           <a:ln w="15875">
             <a:solidFill>
-              <a:srgbClr val="4A5A50"/>
+              <a:srgbClr val="4A5867"/>
             </a:solidFill>
             <a:headEnd type="triangle" w="med" len="med"/>
           </a:ln>
@@ -14744,7 +14744,7 @@
           </a:prstGeom>
           <a:ln w="15875">
             <a:solidFill>
-              <a:srgbClr val="4A5A50"/>
+              <a:srgbClr val="4A5867"/>
             </a:solidFill>
             <a:headEnd type="triangle" w="med" len="med"/>
           </a:ln>
@@ -14783,7 +14783,7 @@
           </a:prstGeom>
           <a:ln w="15875">
             <a:solidFill>
-              <a:srgbClr val="6B7A70"/>
+              <a:srgbClr val="6B7A89"/>
             </a:solidFill>
             <a:prstDash val="dash"/>
             <a:tailEnd type="triangle"/>
@@ -14823,7 +14823,7 @@
           </a:prstGeom>
           <a:ln w="15875">
             <a:solidFill>
-              <a:srgbClr val="6B7A70"/>
+              <a:srgbClr val="6B7A89"/>
             </a:solidFill>
             <a:prstDash val="dash"/>
             <a:tailEnd type="triangle"/>
@@ -14859,7 +14859,7 @@
             <a:avLst/>
           </a:prstGeom>
           <a:solidFill>
-            <a:srgbClr val="1B4D2E"/>
+            <a:srgbClr val="1B4F72"/>
           </a:solidFill>
           <a:ln>
             <a:noFill/>
@@ -14947,7 +14947,7 @@
             <a:r>
               <a:rPr sz="750" b="0" i="0">
                 <a:solidFill>
-                  <a:srgbClr val="5B6B61"/>
+                  <a:srgbClr val="55677A"/>
                 </a:solidFill>
                 <a:latin typeface="Arial"/>
               </a:rPr>
@@ -15059,7 +15059,7 @@
             <a:r>
               <a:rPr sz="994" b="1" i="0">
                 <a:solidFill>
-                  <a:srgbClr val="1E2A22"/>
+                  <a:srgbClr val="1B2733"/>
                 </a:solidFill>
                 <a:latin typeface="Arial"/>
               </a:rPr>
@@ -15068,7 +15068,7 @@
             <a:r>
               <a:rPr sz="1275" b="0" i="0">
                 <a:solidFill>
-                  <a:srgbClr val="1E2A22"/>
+                  <a:srgbClr val="1B2733"/>
                 </a:solidFill>
                 <a:latin typeface="Arial"/>
               </a:rPr>
@@ -15123,7 +15123,7 @@
             <a:r>
               <a:rPr sz="994" b="1" i="0">
                 <a:solidFill>
-                  <a:srgbClr val="1E2A22"/>
+                  <a:srgbClr val="1B2733"/>
                 </a:solidFill>
                 <a:latin typeface="Arial"/>
               </a:rPr>
@@ -15132,7 +15132,7 @@
             <a:r>
               <a:rPr sz="1275" b="0" i="0">
                 <a:solidFill>
-                  <a:srgbClr val="1E2A22"/>
+                  <a:srgbClr val="1B2733"/>
                 </a:solidFill>
                 <a:latin typeface="Arial"/>
               </a:rPr>
@@ -15187,7 +15187,7 @@
             <a:r>
               <a:rPr sz="994" b="1" i="0">
                 <a:solidFill>
-                  <a:srgbClr val="1E2A22"/>
+                  <a:srgbClr val="1B2733"/>
                 </a:solidFill>
                 <a:latin typeface="Arial"/>
               </a:rPr>
@@ -15196,7 +15196,7 @@
             <a:r>
               <a:rPr sz="1275" b="0" i="0">
                 <a:solidFill>
-                  <a:srgbClr val="1E2A22"/>
+                  <a:srgbClr val="1B2733"/>
                 </a:solidFill>
                 <a:latin typeface="Arial"/>
               </a:rPr>
@@ -15251,7 +15251,7 @@
             <a:r>
               <a:rPr sz="994" b="1" i="0">
                 <a:solidFill>
-                  <a:srgbClr val="1E2A22"/>
+                  <a:srgbClr val="1B2733"/>
                 </a:solidFill>
                 <a:latin typeface="Arial"/>
               </a:rPr>
@@ -15260,7 +15260,7 @@
             <a:r>
               <a:rPr sz="1275" b="0" i="0">
                 <a:solidFill>
-                  <a:srgbClr val="1E2A22"/>
+                  <a:srgbClr val="1B2733"/>
                 </a:solidFill>
                 <a:latin typeface="Arial"/>
               </a:rPr>
@@ -15315,7 +15315,7 @@
             <a:r>
               <a:rPr sz="1053" b="1" i="0">
                 <a:solidFill>
-                  <a:srgbClr val="1E2A22"/>
+                  <a:srgbClr val="1B2733"/>
                 </a:solidFill>
                 <a:latin typeface="Arial"/>
               </a:rPr>
@@ -15324,7 +15324,7 @@
             <a:r>
               <a:rPr sz="1350" b="1" i="0">
                 <a:solidFill>
-                  <a:srgbClr val="1E2A22"/>
+                  <a:srgbClr val="1B2733"/>
                 </a:solidFill>
                 <a:latin typeface="Arial"/>
               </a:rPr>
@@ -15379,7 +15379,7 @@
             <a:r>
               <a:rPr sz="1053" b="1" i="0">
                 <a:solidFill>
-                  <a:srgbClr val="1E2A22"/>
+                  <a:srgbClr val="1B2733"/>
                 </a:solidFill>
                 <a:latin typeface="Arial"/>
               </a:rPr>
@@ -15388,7 +15388,7 @@
             <a:r>
               <a:rPr sz="1350" b="1" i="0">
                 <a:solidFill>
-                  <a:srgbClr val="1E2A22"/>
+                  <a:srgbClr val="1B2733"/>
                 </a:solidFill>
                 <a:latin typeface="Arial"/>
               </a:rPr>
@@ -15443,7 +15443,7 @@
             <a:r>
               <a:rPr sz="1053" b="1" i="0">
                 <a:solidFill>
-                  <a:srgbClr val="1E2A22"/>
+                  <a:srgbClr val="1B2733"/>
                 </a:solidFill>
                 <a:latin typeface="Arial"/>
               </a:rPr>
@@ -15452,7 +15452,7 @@
             <a:r>
               <a:rPr sz="1350" b="1" i="0">
                 <a:solidFill>
-                  <a:srgbClr val="1E2A22"/>
+                  <a:srgbClr val="1B2733"/>
                 </a:solidFill>
                 <a:latin typeface="Arial"/>
               </a:rPr>
@@ -15478,11 +15478,11 @@
             </a:avLst>
           </a:prstGeom>
           <a:solidFill>
-            <a:srgbClr val="1B4D2E"/>
+            <a:srgbClr val="1B4F72"/>
           </a:solidFill>
           <a:ln w="12700">
             <a:solidFill>
-              <a:srgbClr val="1B4D2E"/>
+              <a:srgbClr val="1B4F72"/>
             </a:solidFill>
           </a:ln>
           <a:effectLst/>
@@ -15537,7 +15537,7 @@
           </a:solidFill>
           <a:ln w="12700">
             <a:solidFill>
-              <a:srgbClr val="6B7A70"/>
+              <a:srgbClr val="6B7A89"/>
             </a:solidFill>
             <a:prstDash val="dash"/>
           </a:ln>
@@ -15565,7 +15565,7 @@
             <a:r>
               <a:rPr sz="1150" b="1" i="0">
                 <a:solidFill>
-                  <a:srgbClr val="5B6B61"/>
+                  <a:srgbClr val="55677A"/>
                 </a:solidFill>
                 <a:latin typeface="Arial"/>
               </a:rPr>
@@ -15577,7 +15577,7 @@
             <a:r>
               <a:rPr sz="1150" b="0" i="0">
                 <a:solidFill>
-                  <a:srgbClr val="5B6B61"/>
+                  <a:srgbClr val="55677A"/>
                 </a:solidFill>
                 <a:latin typeface="Arial"/>
               </a:rPr>
@@ -15605,7 +15605,7 @@
           </a:solidFill>
           <a:ln w="12700">
             <a:solidFill>
-              <a:srgbClr val="6B7A70"/>
+              <a:srgbClr val="6B7A89"/>
             </a:solidFill>
             <a:prstDash val="dash"/>
           </a:ln>
@@ -15633,7 +15633,7 @@
             <a:r>
               <a:rPr sz="1150" b="1" i="0">
                 <a:solidFill>
-                  <a:srgbClr val="5B6B61"/>
+                  <a:srgbClr val="55677A"/>
                 </a:solidFill>
                 <a:latin typeface="Arial"/>
               </a:rPr>
@@ -15645,7 +15645,7 @@
             <a:r>
               <a:rPr sz="1150" b="0" i="0">
                 <a:solidFill>
-                  <a:srgbClr val="5B6B61"/>
+                  <a:srgbClr val="55677A"/>
                 </a:solidFill>
                 <a:latin typeface="Arial"/>
               </a:rPr>
@@ -15669,11 +15669,11 @@
             <a:avLst/>
           </a:prstGeom>
           <a:solidFill>
-            <a:srgbClr val="E8F0EA"/>
+            <a:srgbClr val="E5EEF6"/>
           </a:solidFill>
           <a:ln w="22225">
             <a:solidFill>
-              <a:srgbClr val="1B4D2E"/>
+              <a:srgbClr val="1B4F72"/>
             </a:solidFill>
           </a:ln>
           <a:effectLst/>
@@ -15700,7 +15700,7 @@
             <a:r>
               <a:rPr sz="1053" b="1" i="0">
                 <a:solidFill>
-                  <a:srgbClr val="1E2A22"/>
+                  <a:srgbClr val="1B2733"/>
                 </a:solidFill>
                 <a:latin typeface="Arial"/>
               </a:rPr>
@@ -15709,7 +15709,7 @@
             <a:r>
               <a:rPr sz="1350" b="1" i="0">
                 <a:solidFill>
-                  <a:srgbClr val="1E2A22"/>
+                  <a:srgbClr val="1B2733"/>
                 </a:solidFill>
                 <a:latin typeface="Arial"/>
               </a:rPr>
@@ -15733,11 +15733,11 @@
             <a:avLst/>
           </a:prstGeom>
           <a:solidFill>
-            <a:srgbClr val="E8F0EA"/>
+            <a:srgbClr val="E5EEF6"/>
           </a:solidFill>
           <a:ln w="22225">
             <a:solidFill>
-              <a:srgbClr val="1B4D2E"/>
+              <a:srgbClr val="1B4F72"/>
             </a:solidFill>
           </a:ln>
           <a:effectLst/>
@@ -15764,7 +15764,7 @@
             <a:r>
               <a:rPr sz="1053" b="1" i="0">
                 <a:solidFill>
-                  <a:srgbClr val="1E2A22"/>
+                  <a:srgbClr val="1B2733"/>
                 </a:solidFill>
                 <a:latin typeface="Arial"/>
               </a:rPr>
@@ -15773,7 +15773,7 @@
             <a:r>
               <a:rPr sz="1350" b="1" i="0">
                 <a:solidFill>
-                  <a:srgbClr val="1E2A22"/>
+                  <a:srgbClr val="1B2733"/>
                 </a:solidFill>
                 <a:latin typeface="Arial"/>
               </a:rPr>
@@ -15797,11 +15797,11 @@
             <a:avLst/>
           </a:prstGeom>
           <a:solidFill>
-            <a:srgbClr val="E8F0EA"/>
+            <a:srgbClr val="E5EEF6"/>
           </a:solidFill>
           <a:ln w="22225">
             <a:solidFill>
-              <a:srgbClr val="1B4D2E"/>
+              <a:srgbClr val="1B4F72"/>
             </a:solidFill>
           </a:ln>
           <a:effectLst/>
@@ -15828,7 +15828,7 @@
             <a:r>
               <a:rPr sz="1053" b="1" i="0">
                 <a:solidFill>
-                  <a:srgbClr val="1E2A22"/>
+                  <a:srgbClr val="1B2733"/>
                 </a:solidFill>
                 <a:latin typeface="Arial"/>
               </a:rPr>
@@ -15837,7 +15837,7 @@
             <a:r>
               <a:rPr sz="1350" b="1" i="0">
                 <a:solidFill>
-                  <a:srgbClr val="1E2A22"/>
+                  <a:srgbClr val="1B2733"/>
                 </a:solidFill>
                 <a:latin typeface="Arial"/>
               </a:rPr>
@@ -15861,11 +15861,11 @@
             <a:avLst/>
           </a:prstGeom>
           <a:solidFill>
-            <a:srgbClr val="F4F8F5"/>
+            <a:srgbClr val="F3F7FA"/>
           </a:solidFill>
           <a:ln w="12700">
             <a:solidFill>
-              <a:srgbClr val="7FA48C"/>
+              <a:srgbClr val="7B9BB5"/>
             </a:solidFill>
           </a:ln>
           <a:effectLst/>
@@ -15892,7 +15892,7 @@
             <a:r>
               <a:rPr sz="955" b="1" i="0">
                 <a:solidFill>
-                  <a:srgbClr val="1E2A22"/>
+                  <a:srgbClr val="1B2733"/>
                 </a:solidFill>
                 <a:latin typeface="Arial"/>
               </a:rPr>
@@ -15901,7 +15901,7 @@
             <a:r>
               <a:rPr sz="1225" b="0" i="0">
                 <a:solidFill>
-                  <a:srgbClr val="1E2A22"/>
+                  <a:srgbClr val="1B2733"/>
                 </a:solidFill>
                 <a:latin typeface="Arial"/>
               </a:rPr>
@@ -15925,11 +15925,11 @@
             <a:avLst/>
           </a:prstGeom>
           <a:solidFill>
-            <a:srgbClr val="F4F8F5"/>
+            <a:srgbClr val="F3F7FA"/>
           </a:solidFill>
           <a:ln w="12700">
             <a:solidFill>
-              <a:srgbClr val="7FA48C"/>
+              <a:srgbClr val="7B9BB5"/>
             </a:solidFill>
           </a:ln>
           <a:effectLst/>
@@ -15956,7 +15956,7 @@
             <a:r>
               <a:rPr sz="955" b="1" i="0">
                 <a:solidFill>
-                  <a:srgbClr val="1E2A22"/>
+                  <a:srgbClr val="1B2733"/>
                 </a:solidFill>
                 <a:latin typeface="Arial"/>
               </a:rPr>
@@ -15965,7 +15965,7 @@
             <a:r>
               <a:rPr sz="1225" b="0" i="0">
                 <a:solidFill>
-                  <a:srgbClr val="1E2A22"/>
+                  <a:srgbClr val="1B2733"/>
                 </a:solidFill>
                 <a:latin typeface="Arial"/>
               </a:rPr>
@@ -15989,11 +15989,11 @@
             <a:avLst/>
           </a:prstGeom>
           <a:solidFill>
-            <a:srgbClr val="F4F8F5"/>
+            <a:srgbClr val="F3F7FA"/>
           </a:solidFill>
           <a:ln w="12700">
             <a:solidFill>
-              <a:srgbClr val="7FA48C"/>
+              <a:srgbClr val="7B9BB5"/>
             </a:solidFill>
           </a:ln>
           <a:effectLst/>
@@ -16020,7 +16020,7 @@
             <a:r>
               <a:rPr sz="955" b="1" i="0">
                 <a:solidFill>
-                  <a:srgbClr val="1E2A22"/>
+                  <a:srgbClr val="1B2733"/>
                 </a:solidFill>
                 <a:latin typeface="Arial"/>
               </a:rPr>
@@ -16029,7 +16029,7 @@
             <a:r>
               <a:rPr sz="1225" b="0" i="0">
                 <a:solidFill>
-                  <a:srgbClr val="1E2A22"/>
+                  <a:srgbClr val="1B2733"/>
                 </a:solidFill>
                 <a:latin typeface="Arial"/>
               </a:rPr>
@@ -16053,11 +16053,11 @@
             <a:avLst/>
           </a:prstGeom>
           <a:solidFill>
-            <a:srgbClr val="F4F8F5"/>
+            <a:srgbClr val="F3F7FA"/>
           </a:solidFill>
           <a:ln w="12700">
             <a:solidFill>
-              <a:srgbClr val="7FA48C"/>
+              <a:srgbClr val="7B9BB5"/>
             </a:solidFill>
           </a:ln>
           <a:effectLst/>
@@ -16084,7 +16084,7 @@
             <a:r>
               <a:rPr sz="955" b="1" i="0">
                 <a:solidFill>
-                  <a:srgbClr val="1E2A22"/>
+                  <a:srgbClr val="1B2733"/>
                 </a:solidFill>
                 <a:latin typeface="Arial"/>
               </a:rPr>
@@ -16093,7 +16093,7 @@
             <a:r>
               <a:rPr sz="1225" b="0" i="0">
                 <a:solidFill>
-                  <a:srgbClr val="1E2A22"/>
+                  <a:srgbClr val="1B2733"/>
                 </a:solidFill>
                 <a:latin typeface="Arial"/>
               </a:rPr>
@@ -16117,11 +16117,11 @@
             <a:avLst/>
           </a:prstGeom>
           <a:solidFill>
-            <a:srgbClr val="F4F8F5"/>
+            <a:srgbClr val="F3F7FA"/>
           </a:solidFill>
           <a:ln w="12700">
             <a:solidFill>
-              <a:srgbClr val="7FA48C"/>
+              <a:srgbClr val="7B9BB5"/>
             </a:solidFill>
           </a:ln>
           <a:effectLst/>
@@ -16148,7 +16148,7 @@
             <a:r>
               <a:rPr sz="955" b="1" i="0">
                 <a:solidFill>
-                  <a:srgbClr val="1E2A22"/>
+                  <a:srgbClr val="1B2733"/>
                 </a:solidFill>
                 <a:latin typeface="Arial"/>
               </a:rPr>
@@ -16157,7 +16157,7 @@
             <a:r>
               <a:rPr sz="1225" b="0" i="0">
                 <a:solidFill>
-                  <a:srgbClr val="1E2A22"/>
+                  <a:srgbClr val="1B2733"/>
                 </a:solidFill>
                 <a:latin typeface="Arial"/>
               </a:rPr>
@@ -16181,11 +16181,11 @@
             <a:avLst/>
           </a:prstGeom>
           <a:solidFill>
-            <a:srgbClr val="F4F8F5"/>
+            <a:srgbClr val="F3F7FA"/>
           </a:solidFill>
           <a:ln w="12700">
             <a:solidFill>
-              <a:srgbClr val="7FA48C"/>
+              <a:srgbClr val="7B9BB5"/>
             </a:solidFill>
           </a:ln>
           <a:effectLst/>
@@ -16212,7 +16212,7 @@
             <a:r>
               <a:rPr sz="955" b="1" i="0">
                 <a:solidFill>
-                  <a:srgbClr val="1E2A22"/>
+                  <a:srgbClr val="1B2733"/>
                 </a:solidFill>
                 <a:latin typeface="Arial"/>
               </a:rPr>
@@ -16221,7 +16221,7 @@
             <a:r>
               <a:rPr sz="1225" b="0" i="0">
                 <a:solidFill>
-                  <a:srgbClr val="1E2A22"/>
+                  <a:srgbClr val="1B2733"/>
                 </a:solidFill>
                 <a:latin typeface="Arial"/>
               </a:rPr>
@@ -16245,11 +16245,11 @@
             <a:avLst/>
           </a:prstGeom>
           <a:solidFill>
-            <a:srgbClr val="F4F8F5"/>
+            <a:srgbClr val="F3F7FA"/>
           </a:solidFill>
           <a:ln w="12700">
             <a:solidFill>
-              <a:srgbClr val="7FA48C"/>
+              <a:srgbClr val="7B9BB5"/>
             </a:solidFill>
           </a:ln>
           <a:effectLst/>
@@ -16276,7 +16276,7 @@
             <a:r>
               <a:rPr sz="955" b="1" i="0">
                 <a:solidFill>
-                  <a:srgbClr val="1E2A22"/>
+                  <a:srgbClr val="1B2733"/>
                 </a:solidFill>
                 <a:latin typeface="Arial"/>
               </a:rPr>
@@ -16285,7 +16285,7 @@
             <a:r>
               <a:rPr sz="1225" b="0" i="0">
                 <a:solidFill>
-                  <a:srgbClr val="1E2A22"/>
+                  <a:srgbClr val="1B2733"/>
                 </a:solidFill>
                 <a:latin typeface="Arial"/>
               </a:rPr>
@@ -16309,11 +16309,11 @@
             <a:avLst/>
           </a:prstGeom>
           <a:solidFill>
-            <a:srgbClr val="F4F8F5"/>
+            <a:srgbClr val="F3F7FA"/>
           </a:solidFill>
           <a:ln w="12700">
             <a:solidFill>
-              <a:srgbClr val="7FA48C"/>
+              <a:srgbClr val="7B9BB5"/>
             </a:solidFill>
           </a:ln>
           <a:effectLst/>
@@ -16340,7 +16340,7 @@
             <a:r>
               <a:rPr sz="955" b="1" i="0">
                 <a:solidFill>
-                  <a:srgbClr val="1E2A22"/>
+                  <a:srgbClr val="1B2733"/>
                 </a:solidFill>
                 <a:latin typeface="Arial"/>
               </a:rPr>
@@ -16349,7 +16349,7 @@
             <a:r>
               <a:rPr sz="1225" b="0" i="0">
                 <a:solidFill>
-                  <a:srgbClr val="1E2A22"/>
+                  <a:srgbClr val="1B2733"/>
                 </a:solidFill>
                 <a:latin typeface="Arial"/>
               </a:rPr>
@@ -16373,11 +16373,11 @@
             <a:avLst/>
           </a:prstGeom>
           <a:solidFill>
-            <a:srgbClr val="F4F8F5"/>
+            <a:srgbClr val="F3F7FA"/>
           </a:solidFill>
           <a:ln w="12700">
             <a:solidFill>
-              <a:srgbClr val="7FA48C"/>
+              <a:srgbClr val="7B9BB5"/>
             </a:solidFill>
           </a:ln>
           <a:effectLst/>
@@ -16404,7 +16404,7 @@
             <a:r>
               <a:rPr sz="955" b="1" i="0">
                 <a:solidFill>
-                  <a:srgbClr val="1E2A22"/>
+                  <a:srgbClr val="1B2733"/>
                 </a:solidFill>
                 <a:latin typeface="Arial"/>
               </a:rPr>
@@ -16413,7 +16413,7 @@
             <a:r>
               <a:rPr sz="1225" b="0" i="0">
                 <a:solidFill>
-                  <a:srgbClr val="1E2A22"/>
+                  <a:srgbClr val="1B2733"/>
                 </a:solidFill>
                 <a:latin typeface="Arial"/>
               </a:rPr>
@@ -16437,11 +16437,11 @@
             <a:avLst/>
           </a:prstGeom>
           <a:solidFill>
-            <a:srgbClr val="F4F8F5"/>
+            <a:srgbClr val="F3F7FA"/>
           </a:solidFill>
           <a:ln w="12700">
             <a:solidFill>
-              <a:srgbClr val="7FA48C"/>
+              <a:srgbClr val="7B9BB5"/>
             </a:solidFill>
           </a:ln>
           <a:effectLst/>
@@ -16468,7 +16468,7 @@
             <a:r>
               <a:rPr sz="955" b="1" i="0">
                 <a:solidFill>
-                  <a:srgbClr val="1E2A22"/>
+                  <a:srgbClr val="1B2733"/>
                 </a:solidFill>
                 <a:latin typeface="Arial"/>
               </a:rPr>
@@ -16477,7 +16477,7 @@
             <a:r>
               <a:rPr sz="1225" b="0" i="0">
                 <a:solidFill>
-                  <a:srgbClr val="1E2A22"/>
+                  <a:srgbClr val="1B2733"/>
                 </a:solidFill>
                 <a:latin typeface="Arial"/>
               </a:rPr>
@@ -16558,7 +16558,7 @@
             <a:r>
               <a:rPr sz="750" b="0" i="0">
                 <a:solidFill>
-                  <a:srgbClr val="5B6B61"/>
+                  <a:srgbClr val="55677A"/>
                 </a:solidFill>
                 <a:latin typeface="Arial"/>
               </a:rPr>
@@ -16639,7 +16639,7 @@
             <a:r>
               <a:rPr sz="750" b="0" i="0">
                 <a:solidFill>
-                  <a:srgbClr val="5B6B61"/>
+                  <a:srgbClr val="55677A"/>
                 </a:solidFill>
                 <a:latin typeface="Arial"/>
               </a:rPr>
@@ -16720,7 +16720,7 @@
             <a:r>
               <a:rPr sz="750" b="0" i="0">
                 <a:solidFill>
-                  <a:srgbClr val="5B6B61"/>
+                  <a:srgbClr val="55677A"/>
                 </a:solidFill>
                 <a:latin typeface="Arial"/>
               </a:rPr>
@@ -16744,11 +16744,11 @@
             <a:avLst/>
           </a:prstGeom>
           <a:solidFill>
-            <a:srgbClr val="1B4D2E"/>
+            <a:srgbClr val="1B4F72"/>
           </a:solidFill>
           <a:ln>
             <a:solidFill>
-              <a:srgbClr val="1B4D2E"/>
+              <a:srgbClr val="1B4F72"/>
             </a:solidFill>
           </a:ln>
           <a:effectLst/>
@@ -16801,7 +16801,7 @@
             <a:r>
               <a:rPr sz="750" b="0" i="0">
                 <a:solidFill>
-                  <a:srgbClr val="5B6B61"/>
+                  <a:srgbClr val="55677A"/>
                 </a:solidFill>
                 <a:latin typeface="Arial"/>
               </a:rPr>
@@ -16825,11 +16825,11 @@
             <a:avLst/>
           </a:prstGeom>
           <a:solidFill>
-            <a:srgbClr val="E8F0EA"/>
+            <a:srgbClr val="E5EEF6"/>
           </a:solidFill>
           <a:ln>
             <a:solidFill>
-              <a:srgbClr val="1B4D2E"/>
+              <a:srgbClr val="1B4F72"/>
             </a:solidFill>
           </a:ln>
           <a:effectLst/>
@@ -16882,7 +16882,7 @@
             <a:r>
               <a:rPr sz="750" b="0" i="0">
                 <a:solidFill>
-                  <a:srgbClr val="5B6B61"/>
+                  <a:srgbClr val="55677A"/>
                 </a:solidFill>
                 <a:latin typeface="Arial"/>
               </a:rPr>
@@ -16906,11 +16906,11 @@
             <a:avLst/>
           </a:prstGeom>
           <a:solidFill>
-            <a:srgbClr val="F4F8F5"/>
+            <a:srgbClr val="F3F7FA"/>
           </a:solidFill>
           <a:ln>
             <a:solidFill>
-              <a:srgbClr val="7FA48C"/>
+              <a:srgbClr val="7B9BB5"/>
             </a:solidFill>
           </a:ln>
           <a:effectLst/>
@@ -16963,7 +16963,7 @@
             <a:r>
               <a:rPr sz="750" b="0" i="0">
                 <a:solidFill>
-                  <a:srgbClr val="5B6B61"/>
+                  <a:srgbClr val="55677A"/>
                 </a:solidFill>
                 <a:latin typeface="Arial"/>
               </a:rPr>
@@ -16991,7 +16991,7 @@
           </a:solidFill>
           <a:ln>
             <a:solidFill>
-              <a:srgbClr val="6B7A70"/>
+              <a:srgbClr val="6B7A89"/>
             </a:solidFill>
             <a:prstDash val="dash"/>
           </a:ln>
@@ -17045,7 +17045,7 @@
             <a:r>
               <a:rPr sz="750" b="0" i="0">
                 <a:solidFill>
-                  <a:srgbClr val="5B6B61"/>
+                  <a:srgbClr val="55677A"/>
                 </a:solidFill>
                 <a:latin typeface="Arial"/>
               </a:rPr>

</xml_diff>